<commit_message>
modify 60 mux demux
</commit_message>
<xml_diff>
--- a/26fall/1860/Lecture/Week1.5/Lab 1.5.2 HDL & CAD LAB 2.pptx
+++ b/26fall/1860/Lecture/Week1.5/Lab 1.5.2 HDL & CAD LAB 2.pptx
@@ -5,7 +5,7 @@
     <p:sldMasterId id="2147483664" r:id="rId1"/>
   </p:sldMasterIdLst>
   <p:notesMasterIdLst>
-    <p:notesMasterId r:id="rId31"/>
+    <p:notesMasterId r:id="rId33"/>
   </p:notesMasterIdLst>
   <p:sldIdLst>
     <p:sldId id="256" r:id="rId2"/>
@@ -26,45 +26,47 @@
     <p:sldId id="1904" r:id="rId17"/>
     <p:sldId id="1927" r:id="rId18"/>
     <p:sldId id="1932" r:id="rId19"/>
-    <p:sldId id="1928" r:id="rId20"/>
-    <p:sldId id="1933" r:id="rId21"/>
-    <p:sldId id="1905" r:id="rId22"/>
-    <p:sldId id="1934" r:id="rId23"/>
-    <p:sldId id="1930" r:id="rId24"/>
-    <p:sldId id="1935" r:id="rId25"/>
-    <p:sldId id="1929" r:id="rId26"/>
-    <p:sldId id="1936" r:id="rId27"/>
-    <p:sldId id="1921" r:id="rId28"/>
-    <p:sldId id="1903" r:id="rId29"/>
-    <p:sldId id="1919" r:id="rId30"/>
+    <p:sldId id="1937" r:id="rId20"/>
+    <p:sldId id="1928" r:id="rId21"/>
+    <p:sldId id="1933" r:id="rId22"/>
+    <p:sldId id="1905" r:id="rId23"/>
+    <p:sldId id="1934" r:id="rId24"/>
+    <p:sldId id="1930" r:id="rId25"/>
+    <p:sldId id="1935" r:id="rId26"/>
+    <p:sldId id="1938" r:id="rId27"/>
+    <p:sldId id="1929" r:id="rId28"/>
+    <p:sldId id="1936" r:id="rId29"/>
+    <p:sldId id="1921" r:id="rId30"/>
+    <p:sldId id="1903" r:id="rId31"/>
+    <p:sldId id="1919" r:id="rId32"/>
   </p:sldIdLst>
   <p:sldSz cx="9144000" cy="5143500" type="screen16x9"/>
   <p:notesSz cx="6858000" cy="9144000"/>
   <p:embeddedFontLst>
     <p:embeddedFont>
       <p:font typeface="Cambria" panose="02040503050406030204" pitchFamily="18" charset="0"/>
-      <p:regular r:id="rId32"/>
-      <p:bold r:id="rId33"/>
-      <p:italic r:id="rId34"/>
-      <p:boldItalic r:id="rId35"/>
+      <p:regular r:id="rId34"/>
+      <p:bold r:id="rId35"/>
+      <p:italic r:id="rId36"/>
+      <p:boldItalic r:id="rId37"/>
     </p:embeddedFont>
     <p:embeddedFont>
       <p:font typeface="Cambria Math" panose="02040503050406030204" pitchFamily="18" charset="0"/>
-      <p:regular r:id="rId36"/>
+      <p:regular r:id="rId38"/>
     </p:embeddedFont>
     <p:embeddedFont>
       <p:font typeface="Consolas" panose="020B0609020204030204" pitchFamily="49" charset="0"/>
-      <p:regular r:id="rId37"/>
-      <p:bold r:id="rId38"/>
-      <p:italic r:id="rId39"/>
-      <p:boldItalic r:id="rId40"/>
+      <p:regular r:id="rId39"/>
+      <p:bold r:id="rId40"/>
+      <p:italic r:id="rId41"/>
+      <p:boldItalic r:id="rId42"/>
     </p:embeddedFont>
     <p:embeddedFont>
       <p:font typeface="Roboto Mono" panose="00000009000000000000" pitchFamily="49" charset="0"/>
-      <p:regular r:id="rId41"/>
-      <p:bold r:id="rId42"/>
-      <p:italic r:id="rId43"/>
-      <p:boldItalic r:id="rId44"/>
+      <p:regular r:id="rId43"/>
+      <p:bold r:id="rId44"/>
+      <p:italic r:id="rId45"/>
+      <p:boldItalic r:id="rId46"/>
     </p:embeddedFont>
   </p:embeddedFontLst>
   <p:defaultTextStyle>
@@ -1290,6 +1292,156 @@
 </p:notes>
 </file>
 
+<file path=ppt/notesSlides/notesSlide5.xml><?xml version="1.0" encoding="utf-8"?>
+<p:notes xmlns:a="http://schemas.openxmlformats.org/drawingml/2006/main" xmlns:r="http://schemas.openxmlformats.org/officeDocument/2006/relationships" xmlns:p="http://schemas.openxmlformats.org/presentationml/2006/main">
+  <p:cSld>
+    <p:spTree>
+      <p:nvGrpSpPr>
+        <p:cNvPr id="1" name=""/>
+        <p:cNvGrpSpPr/>
+        <p:nvPr/>
+      </p:nvGrpSpPr>
+      <p:grpSpPr>
+        <a:xfrm>
+          <a:off x="0" y="0"/>
+          <a:ext cx="0" cy="0"/>
+          <a:chOff x="0" y="0"/>
+          <a:chExt cx="0" cy="0"/>
+        </a:xfrm>
+      </p:grpSpPr>
+      <p:sp>
+        <p:nvSpPr>
+          <p:cNvPr id="2" name="幻灯片图像占位符 1"/>
+          <p:cNvSpPr>
+            <a:spLocks noGrp="1" noRot="1" noChangeAspect="1"/>
+          </p:cNvSpPr>
+          <p:nvPr>
+            <p:ph type="sldImg"/>
+          </p:nvPr>
+        </p:nvSpPr>
+        <p:spPr>
+          <a:xfrm>
+            <a:off x="381000" y="685800"/>
+            <a:ext cx="6096000" cy="3429000"/>
+          </a:xfrm>
+        </p:spPr>
+      </p:sp>
+      <p:sp>
+        <p:nvSpPr>
+          <p:cNvPr id="3" name="备注占位符 2"/>
+          <p:cNvSpPr>
+            <a:spLocks noGrp="1"/>
+          </p:cNvSpPr>
+          <p:nvPr>
+            <p:ph type="body" idx="1"/>
+          </p:nvPr>
+        </p:nvSpPr>
+        <p:spPr/>
+        <p:txBody>
+          <a:bodyPr/>
+          <a:lstStyle/>
+          <a:p>
+            <a:endParaRPr lang="zh-CN" altLang="en-US"/>
+          </a:p>
+        </p:txBody>
+      </p:sp>
+    </p:spTree>
+    <p:extLst>
+      <p:ext uri="{BB962C8B-B14F-4D97-AF65-F5344CB8AC3E}">
+        <p14:creationId xmlns:p14="http://schemas.microsoft.com/office/powerpoint/2010/main" val="353143270"/>
+      </p:ext>
+    </p:extLst>
+  </p:cSld>
+  <p:clrMapOvr>
+    <a:masterClrMapping/>
+  </p:clrMapOvr>
+</p:notes>
+</file>
+
+<file path=ppt/notesSlides/notesSlide6.xml><?xml version="1.0" encoding="utf-8"?>
+<p:notes xmlns:a="http://schemas.openxmlformats.org/drawingml/2006/main" xmlns:r="http://schemas.openxmlformats.org/officeDocument/2006/relationships" xmlns:p="http://schemas.openxmlformats.org/presentationml/2006/main">
+  <p:cSld>
+    <p:spTree>
+      <p:nvGrpSpPr>
+        <p:cNvPr id="1" name="">
+          <a:extLst>
+            <a:ext uri="{FF2B5EF4-FFF2-40B4-BE49-F238E27FC236}">
+              <a16:creationId xmlns:a16="http://schemas.microsoft.com/office/drawing/2014/main" id="{11BDB15F-14F1-9C06-8C76-2615F682A085}"/>
+            </a:ext>
+          </a:extLst>
+        </p:cNvPr>
+        <p:cNvGrpSpPr/>
+        <p:nvPr/>
+      </p:nvGrpSpPr>
+      <p:grpSpPr>
+        <a:xfrm>
+          <a:off x="0" y="0"/>
+          <a:ext cx="0" cy="0"/>
+          <a:chOff x="0" y="0"/>
+          <a:chExt cx="0" cy="0"/>
+        </a:xfrm>
+      </p:grpSpPr>
+      <p:sp>
+        <p:nvSpPr>
+          <p:cNvPr id="2" name="幻灯片图像占位符 1">
+            <a:extLst>
+              <a:ext uri="{FF2B5EF4-FFF2-40B4-BE49-F238E27FC236}">
+                <a16:creationId xmlns:a16="http://schemas.microsoft.com/office/drawing/2014/main" id="{7FDC5045-242A-B2F5-1286-84561EF25A3A}"/>
+              </a:ext>
+            </a:extLst>
+          </p:cNvPr>
+          <p:cNvSpPr>
+            <a:spLocks noGrp="1" noRot="1" noChangeAspect="1"/>
+          </p:cNvSpPr>
+          <p:nvPr>
+            <p:ph type="sldImg"/>
+          </p:nvPr>
+        </p:nvSpPr>
+        <p:spPr>
+          <a:xfrm>
+            <a:off x="381000" y="685800"/>
+            <a:ext cx="6096000" cy="3429000"/>
+          </a:xfrm>
+        </p:spPr>
+      </p:sp>
+      <p:sp>
+        <p:nvSpPr>
+          <p:cNvPr id="3" name="备注占位符 2">
+            <a:extLst>
+              <a:ext uri="{FF2B5EF4-FFF2-40B4-BE49-F238E27FC236}">
+                <a16:creationId xmlns:a16="http://schemas.microsoft.com/office/drawing/2014/main" id="{CBC3130F-CFB3-8B03-5A28-FCD6F237EFF6}"/>
+              </a:ext>
+            </a:extLst>
+          </p:cNvPr>
+          <p:cNvSpPr>
+            <a:spLocks noGrp="1"/>
+          </p:cNvSpPr>
+          <p:nvPr>
+            <p:ph type="body" idx="1"/>
+          </p:nvPr>
+        </p:nvSpPr>
+        <p:spPr/>
+        <p:txBody>
+          <a:bodyPr/>
+          <a:lstStyle/>
+          <a:p>
+            <a:endParaRPr lang="zh-CN" altLang="en-US"/>
+          </a:p>
+        </p:txBody>
+      </p:sp>
+    </p:spTree>
+    <p:extLst>
+      <p:ext uri="{BB962C8B-B14F-4D97-AF65-F5344CB8AC3E}">
+        <p14:creationId xmlns:p14="http://schemas.microsoft.com/office/powerpoint/2010/main" val="1255432180"/>
+      </p:ext>
+    </p:extLst>
+  </p:cSld>
+  <p:clrMapOvr>
+    <a:masterClrMapping/>
+  </p:clrMapOvr>
+</p:notes>
+</file>
+
 <file path=ppt/slideLayouts/slideLayout1.xml><?xml version="1.0" encoding="utf-8"?>
 <p:sldLayout xmlns:a="http://schemas.openxmlformats.org/drawingml/2006/main" xmlns:r="http://schemas.openxmlformats.org/officeDocument/2006/relationships" xmlns:p="http://schemas.openxmlformats.org/presentationml/2006/main" matchingName="Text + 2 Images">
   <p:cSld name="Text + 2 Images">
@@ -3904,7 +4056,7 @@
           <a:p>
             <a:fld id="{1663657D-8E22-4681-BD7E-16E8F6F56673}" type="datetimeFigureOut">
               <a:rPr lang="en-FI" smtClean="0"/>
-              <a:t>10/28/2026</a:t>
+              <a:t>10/30/2026</a:t>
             </a:fld>
             <a:endParaRPr lang="en-FI"/>
           </a:p>
@@ -24745,6 +24897,1450 @@
   <p:cSld>
     <p:spTree>
       <p:nvGrpSpPr>
+        <p:cNvPr id="1" name=""/>
+        <p:cNvGrpSpPr/>
+        <p:nvPr/>
+      </p:nvGrpSpPr>
+      <p:grpSpPr>
+        <a:xfrm>
+          <a:off x="0" y="0"/>
+          <a:ext cx="0" cy="0"/>
+          <a:chOff x="0" y="0"/>
+          <a:chExt cx="0" cy="0"/>
+        </a:xfrm>
+      </p:grpSpPr>
+      <p:sp>
+        <p:nvSpPr>
+          <p:cNvPr id="2" name="文本占位符 1">
+            <a:extLst>
+              <a:ext uri="{FF2B5EF4-FFF2-40B4-BE49-F238E27FC236}">
+                <a16:creationId xmlns:a16="http://schemas.microsoft.com/office/drawing/2014/main" id="{D3E9D136-CB8B-EFED-9DCA-5DCB0DEB55D3}"/>
+              </a:ext>
+            </a:extLst>
+          </p:cNvPr>
+          <p:cNvSpPr>
+            <a:spLocks noGrp="1"/>
+          </p:cNvSpPr>
+          <p:nvPr>
+            <p:ph type="body" idx="1"/>
+          </p:nvPr>
+        </p:nvSpPr>
+        <p:spPr>
+          <a:xfrm>
+            <a:off x="339724" y="1045790"/>
+            <a:ext cx="7798435" cy="3846249"/>
+          </a:xfrm>
+        </p:spPr>
+        <p:txBody>
+          <a:bodyPr/>
+          <a:lstStyle/>
+          <a:p>
+            <a:pPr marL="571500" indent="-342900">
+              <a:buAutoNum type="arabicPeriod"/>
+            </a:pPr>
+            <a:r>
+              <a:rPr lang="en-US" altLang="zh-CN" sz="1400"/>
+              <a:t>N</a:t>
+            </a:r>
+            <a:r>
+              <a:rPr lang="zh-CN" altLang="en-US" sz="1400"/>
+              <a:t>路输入信号需要</a:t>
+            </a:r>
+            <a:r>
+              <a:rPr lang="en-US" altLang="zh-CN" sz="1400"/>
+              <a:t>N</a:t>
+            </a:r>
+            <a:r>
+              <a:rPr lang="zh-CN" altLang="en-US" sz="1400"/>
+              <a:t>个</a:t>
+            </a:r>
+            <a:r>
+              <a:rPr lang="en-US" altLang="zh-CN" sz="1400"/>
+              <a:t>And</a:t>
+            </a:r>
+            <a:r>
+              <a:rPr lang="zh-CN" altLang="en-US" sz="1400"/>
+              <a:t>门</a:t>
+            </a:r>
+            <a:endParaRPr lang="en-US" altLang="zh-CN" sz="1400"/>
+          </a:p>
+          <a:p>
+            <a:pPr marL="571500" indent="-342900">
+              <a:buAutoNum type="arabicPeriod"/>
+            </a:pPr>
+            <a:r>
+              <a:rPr lang="zh-CN" altLang="en-US" sz="1400"/>
+              <a:t>将每路输入信号接到</a:t>
+            </a:r>
+            <a:r>
+              <a:rPr lang="en-US" altLang="zh-CN" sz="1400"/>
+              <a:t>And</a:t>
+            </a:r>
+            <a:r>
+              <a:rPr lang="zh-CN" altLang="en-US" sz="1400"/>
+              <a:t>的</a:t>
+            </a:r>
+            <a:r>
+              <a:rPr lang="en-US" altLang="zh-CN" sz="1400"/>
+              <a:t>a</a:t>
+            </a:r>
+            <a:r>
+              <a:rPr lang="zh-CN" altLang="en-US" sz="1400"/>
+              <a:t>输入上，</a:t>
+            </a:r>
+            <a:r>
+              <a:rPr lang="en-US" altLang="zh-CN" sz="1400"/>
+              <a:t>b</a:t>
+            </a:r>
+            <a:r>
+              <a:rPr lang="zh-CN" altLang="en-US" sz="1400"/>
+              <a:t>输入留给</a:t>
+            </a:r>
+            <a:r>
+              <a:rPr lang="en-US" altLang="zh-CN" sz="1400"/>
+              <a:t>sel</a:t>
+            </a:r>
+          </a:p>
+          <a:p>
+            <a:pPr marL="571500" indent="-342900">
+              <a:buAutoNum type="arabicPeriod"/>
+            </a:pPr>
+            <a:r>
+              <a:rPr lang="en-US" altLang="zh-CN" sz="1400"/>
+              <a:t>2way</a:t>
+            </a:r>
+            <a:r>
+              <a:rPr lang="zh-CN" altLang="en-US" sz="1400"/>
+              <a:t>、</a:t>
+            </a:r>
+            <a:r>
+              <a:rPr lang="en-US" altLang="zh-CN" sz="1400"/>
+              <a:t>4way</a:t>
+            </a:r>
+            <a:r>
+              <a:rPr lang="zh-CN" altLang="en-US" sz="1400"/>
+              <a:t>、</a:t>
+            </a:r>
+            <a:r>
+              <a:rPr lang="en-US" altLang="zh-CN" sz="1400"/>
+              <a:t>8way</a:t>
+            </a:r>
+            <a:r>
+              <a:rPr lang="zh-CN" altLang="en-US" sz="1400"/>
+              <a:t>、</a:t>
+            </a:r>
+            <a:r>
+              <a:rPr lang="en-US" altLang="zh-CN" sz="1400"/>
+              <a:t>16way</a:t>
+            </a:r>
+            <a:r>
+              <a:rPr lang="zh-CN" altLang="en-US" sz="1400"/>
+              <a:t>分别要</a:t>
+            </a:r>
+            <a:r>
+              <a:rPr lang="en-US" altLang="zh-CN" sz="1400"/>
+              <a:t>1</a:t>
+            </a:r>
+            <a:r>
+              <a:rPr lang="zh-CN" altLang="en-US" sz="1400"/>
+              <a:t>、</a:t>
+            </a:r>
+            <a:r>
+              <a:rPr lang="en-US" altLang="zh-CN" sz="1400"/>
+              <a:t>2</a:t>
+            </a:r>
+            <a:r>
+              <a:rPr lang="zh-CN" altLang="en-US" sz="1400"/>
+              <a:t>、</a:t>
+            </a:r>
+            <a:r>
+              <a:rPr lang="en-US" altLang="zh-CN" sz="1400"/>
+              <a:t>3</a:t>
+            </a:r>
+            <a:r>
+              <a:rPr lang="zh-CN" altLang="en-US" sz="1400"/>
+              <a:t>、</a:t>
+            </a:r>
+            <a:r>
+              <a:rPr lang="en-US" altLang="zh-CN" sz="1400"/>
+              <a:t>4</a:t>
+            </a:r>
+            <a:r>
+              <a:rPr lang="zh-CN" altLang="en-US" sz="1400"/>
+              <a:t>根</a:t>
+            </a:r>
+            <a:r>
+              <a:rPr lang="en-US" altLang="zh-CN" sz="1400"/>
+              <a:t>sel</a:t>
+            </a:r>
+          </a:p>
+          <a:p>
+            <a:pPr marL="571500" indent="-342900">
+              <a:buAutoNum type="arabicPeriod"/>
+            </a:pPr>
+            <a:r>
+              <a:rPr lang="zh-CN" altLang="en-US" sz="1400"/>
+              <a:t>以</a:t>
+            </a:r>
+            <a:r>
+              <a:rPr lang="en-US" altLang="zh-CN" sz="1400"/>
+              <a:t>4way</a:t>
+            </a:r>
+            <a:r>
+              <a:rPr lang="zh-CN" altLang="en-US" sz="1400"/>
+              <a:t>为例，列出真值表：</a:t>
+            </a:r>
+            <a:endParaRPr lang="en-US" altLang="zh-CN" sz="1400"/>
+          </a:p>
+          <a:p>
+            <a:pPr marL="571500" indent="-342900">
+              <a:buAutoNum type="arabicPeriod"/>
+            </a:pPr>
+            <a:endParaRPr lang="en-US" altLang="zh-CN" sz="1400"/>
+          </a:p>
+          <a:p>
+            <a:pPr marL="571500" indent="-342900">
+              <a:buAutoNum type="arabicPeriod"/>
+            </a:pPr>
+            <a:endParaRPr lang="en-US" altLang="zh-CN" sz="1400"/>
+          </a:p>
+          <a:p>
+            <a:pPr marL="571500" indent="-342900">
+              <a:buAutoNum type="arabicPeriod"/>
+            </a:pPr>
+            <a:endParaRPr lang="en-US" altLang="zh-CN" sz="1400"/>
+          </a:p>
+          <a:p>
+            <a:pPr marL="571500" indent="-342900">
+              <a:buAutoNum type="arabicPeriod"/>
+            </a:pPr>
+            <a:endParaRPr lang="en-US" altLang="zh-CN" sz="1400"/>
+          </a:p>
+          <a:p>
+            <a:pPr marL="571500" indent="-342900">
+              <a:buAutoNum type="arabicPeriod"/>
+            </a:pPr>
+            <a:endParaRPr lang="en-US" altLang="zh-CN" sz="1400"/>
+          </a:p>
+          <a:p>
+            <a:pPr marL="228600" indent="0"/>
+            <a:r>
+              <a:rPr lang="en-US" altLang="zh-CN" sz="1400">
+                <a:solidFill>
+                  <a:schemeClr val="accent2"/>
+                </a:solidFill>
+              </a:rPr>
+              <a:t>Mux</a:t>
+            </a:r>
+            <a:r>
+              <a:rPr lang="zh-CN" altLang="en-US" sz="1400">
+                <a:solidFill>
+                  <a:schemeClr val="accent2"/>
+                </a:solidFill>
+              </a:rPr>
+              <a:t>电路的核心是用</a:t>
+            </a:r>
+            <a:r>
+              <a:rPr lang="en-US" altLang="zh-CN" sz="1400">
+                <a:solidFill>
+                  <a:schemeClr val="accent2"/>
+                </a:solidFill>
+              </a:rPr>
+              <a:t>S1S0</a:t>
+            </a:r>
+            <a:r>
+              <a:rPr lang="zh-CN" altLang="en-US" sz="1400">
+                <a:solidFill>
+                  <a:schemeClr val="accent2"/>
+                </a:solidFill>
+              </a:rPr>
+              <a:t>组合成</a:t>
+            </a:r>
+            <a:r>
+              <a:rPr lang="en-US" altLang="zh-CN" sz="1400">
+                <a:solidFill>
+                  <a:schemeClr val="accent2"/>
+                </a:solidFill>
+              </a:rPr>
+              <a:t>b</a:t>
+            </a:r>
+            <a:r>
+              <a:rPr lang="zh-CN" altLang="en-US" sz="1400">
+                <a:solidFill>
+                  <a:schemeClr val="accent2"/>
+                </a:solidFill>
+              </a:rPr>
+              <a:t>信号，再接到</a:t>
+            </a:r>
+            <a:r>
+              <a:rPr lang="en-US" altLang="zh-CN" sz="1400">
+                <a:solidFill>
+                  <a:schemeClr val="accent2"/>
+                </a:solidFill>
+              </a:rPr>
+              <a:t>and</a:t>
+            </a:r>
+            <a:r>
+              <a:rPr lang="zh-CN" altLang="en-US" sz="1400">
+                <a:solidFill>
+                  <a:schemeClr val="accent2"/>
+                </a:solidFill>
+              </a:rPr>
+              <a:t>门的</a:t>
+            </a:r>
+            <a:r>
+              <a:rPr lang="en-US" altLang="zh-CN" sz="1400">
+                <a:solidFill>
+                  <a:schemeClr val="accent2"/>
+                </a:solidFill>
+              </a:rPr>
+              <a:t>b</a:t>
+            </a:r>
+            <a:r>
+              <a:rPr lang="zh-CN" altLang="en-US" sz="1400">
+                <a:solidFill>
+                  <a:schemeClr val="accent2"/>
+                </a:solidFill>
+              </a:rPr>
+              <a:t>信号上</a:t>
+            </a:r>
+            <a:endParaRPr lang="en-US" altLang="zh-CN" sz="1400">
+              <a:solidFill>
+                <a:schemeClr val="accent2"/>
+              </a:solidFill>
+            </a:endParaRPr>
+          </a:p>
+          <a:p>
+            <a:pPr marL="228600" indent="0"/>
+            <a:r>
+              <a:rPr lang="en-US" altLang="zh-CN" sz="1400">
+                <a:solidFill>
+                  <a:schemeClr val="accent2"/>
+                </a:solidFill>
+              </a:rPr>
+              <a:t>5. </a:t>
+            </a:r>
+            <a:r>
+              <a:rPr lang="zh-CN" altLang="en-US" sz="1400">
+                <a:solidFill>
+                  <a:schemeClr val="accent2"/>
+                </a:solidFill>
+              </a:rPr>
+              <a:t>如果是</a:t>
+            </a:r>
+            <a:r>
+              <a:rPr lang="en-US" altLang="zh-CN" sz="1400">
+                <a:solidFill>
+                  <a:schemeClr val="accent2"/>
+                </a:solidFill>
+              </a:rPr>
+              <a:t>16bits</a:t>
+            </a:r>
+            <a:r>
+              <a:rPr lang="zh-CN" altLang="en-US" sz="1400">
+                <a:solidFill>
+                  <a:schemeClr val="accent2"/>
+                </a:solidFill>
+              </a:rPr>
+              <a:t>，用</a:t>
+            </a:r>
+            <a:r>
+              <a:rPr lang="en-US" altLang="zh-CN" sz="1400">
+                <a:solidFill>
+                  <a:schemeClr val="accent2"/>
+                </a:solidFill>
+              </a:rPr>
+              <a:t>And16</a:t>
+            </a:r>
+            <a:r>
+              <a:rPr lang="zh-CN" altLang="en-US" sz="1400">
+                <a:solidFill>
+                  <a:schemeClr val="accent2"/>
+                </a:solidFill>
+              </a:rPr>
+              <a:t>、</a:t>
+            </a:r>
+            <a:r>
+              <a:rPr lang="en-US" altLang="zh-CN" sz="1400">
+                <a:solidFill>
+                  <a:schemeClr val="accent2"/>
+                </a:solidFill>
+              </a:rPr>
+              <a:t>Not16</a:t>
+            </a:r>
+            <a:r>
+              <a:rPr lang="zh-CN" altLang="en-US" sz="1400">
+                <a:solidFill>
+                  <a:schemeClr val="accent2"/>
+                </a:solidFill>
+              </a:rPr>
+              <a:t>；注意要把</a:t>
+            </a:r>
+            <a:r>
+              <a:rPr lang="en-US" altLang="zh-CN" sz="1400">
+                <a:solidFill>
+                  <a:schemeClr val="accent2"/>
+                </a:solidFill>
+              </a:rPr>
+              <a:t>b</a:t>
+            </a:r>
+            <a:r>
+              <a:rPr lang="zh-CN" altLang="en-US" sz="1400">
+                <a:solidFill>
+                  <a:schemeClr val="accent2"/>
+                </a:solidFill>
+              </a:rPr>
+              <a:t>信号由</a:t>
+            </a:r>
+            <a:r>
+              <a:rPr lang="en-US" altLang="zh-CN" sz="1400">
+                <a:solidFill>
+                  <a:schemeClr val="accent2"/>
+                </a:solidFill>
+              </a:rPr>
+              <a:t>1-bit</a:t>
+            </a:r>
+            <a:r>
+              <a:rPr lang="zh-CN" altLang="en-US" sz="1400">
+                <a:solidFill>
+                  <a:schemeClr val="accent2"/>
+                </a:solidFill>
+              </a:rPr>
+              <a:t>扩展成</a:t>
+            </a:r>
+            <a:r>
+              <a:rPr lang="en-US" altLang="zh-CN" sz="1400">
+                <a:solidFill>
+                  <a:schemeClr val="accent2"/>
+                </a:solidFill>
+              </a:rPr>
+              <a:t>16-bits</a:t>
+            </a:r>
+            <a:r>
+              <a:rPr lang="zh-CN" altLang="en-US" sz="1400">
+                <a:solidFill>
+                  <a:schemeClr val="accent2"/>
+                </a:solidFill>
+              </a:rPr>
+              <a:t>，接到</a:t>
+            </a:r>
+            <a:r>
+              <a:rPr lang="en-US" altLang="zh-CN" sz="1400">
+                <a:solidFill>
+                  <a:schemeClr val="accent2"/>
+                </a:solidFill>
+              </a:rPr>
+              <a:t>and</a:t>
+            </a:r>
+            <a:r>
+              <a:rPr lang="zh-CN" altLang="en-US" sz="1400">
+                <a:solidFill>
+                  <a:schemeClr val="accent2"/>
+                </a:solidFill>
+              </a:rPr>
+              <a:t>门的</a:t>
+            </a:r>
+            <a:r>
+              <a:rPr lang="en-US" altLang="zh-CN" sz="1400">
+                <a:solidFill>
+                  <a:schemeClr val="accent2"/>
+                </a:solidFill>
+              </a:rPr>
+              <a:t>b</a:t>
+            </a:r>
+            <a:r>
+              <a:rPr lang="zh-CN" altLang="en-US" sz="1400">
+                <a:solidFill>
+                  <a:schemeClr val="accent2"/>
+                </a:solidFill>
+              </a:rPr>
+              <a:t>信号上</a:t>
+            </a:r>
+            <a:endParaRPr lang="en-US" altLang="zh-CN" sz="1400">
+              <a:solidFill>
+                <a:schemeClr val="accent2"/>
+              </a:solidFill>
+            </a:endParaRPr>
+          </a:p>
+          <a:p>
+            <a:pPr marL="228600" indent="0"/>
+            <a:endParaRPr lang="en-US" altLang="zh-CN" sz="1400"/>
+          </a:p>
+          <a:p>
+            <a:pPr marL="571500" indent="-342900">
+              <a:buAutoNum type="arabicPeriod"/>
+            </a:pPr>
+            <a:endParaRPr lang="zh-CN" altLang="en-US" sz="1600"/>
+          </a:p>
+        </p:txBody>
+      </p:sp>
+      <p:sp>
+        <p:nvSpPr>
+          <p:cNvPr id="3" name="文本占位符 2">
+            <a:extLst>
+              <a:ext uri="{FF2B5EF4-FFF2-40B4-BE49-F238E27FC236}">
+                <a16:creationId xmlns:a16="http://schemas.microsoft.com/office/drawing/2014/main" id="{D3EBA472-CB21-457E-9990-34892732F4B8}"/>
+              </a:ext>
+            </a:extLst>
+          </p:cNvPr>
+          <p:cNvSpPr>
+            <a:spLocks noGrp="1"/>
+          </p:cNvSpPr>
+          <p:nvPr>
+            <p:ph type="body" idx="2"/>
+          </p:nvPr>
+        </p:nvSpPr>
+        <p:spPr>
+          <a:xfrm>
+            <a:off x="339725" y="377428"/>
+            <a:ext cx="6421157" cy="621000"/>
+          </a:xfrm>
+        </p:spPr>
+        <p:txBody>
+          <a:bodyPr/>
+          <a:lstStyle/>
+          <a:p>
+            <a:r>
+              <a:rPr lang="en-US" altLang="zh-CN"/>
+              <a:t>2/4/8/16-Way 1-bit MUX</a:t>
+            </a:r>
+            <a:r>
+              <a:rPr lang="zh-CN" altLang="en-US"/>
+              <a:t>通用电路图</a:t>
+            </a:r>
+            <a:endParaRPr lang="en-US" altLang="zh-CN"/>
+          </a:p>
+          <a:p>
+            <a:endParaRPr lang="zh-CN" altLang="en-US"/>
+          </a:p>
+        </p:txBody>
+      </p:sp>
+      <p:sp>
+        <p:nvSpPr>
+          <p:cNvPr id="4" name="灯片编号占位符 3">
+            <a:extLst>
+              <a:ext uri="{FF2B5EF4-FFF2-40B4-BE49-F238E27FC236}">
+                <a16:creationId xmlns:a16="http://schemas.microsoft.com/office/drawing/2014/main" id="{DFB9AAAB-81E9-3FFF-F177-4A3871EDF06F}"/>
+              </a:ext>
+            </a:extLst>
+          </p:cNvPr>
+          <p:cNvSpPr>
+            <a:spLocks noGrp="1"/>
+          </p:cNvSpPr>
+          <p:nvPr>
+            <p:ph type="sldNum" idx="12"/>
+          </p:nvPr>
+        </p:nvSpPr>
+        <p:spPr/>
+        <p:txBody>
+          <a:bodyPr/>
+          <a:lstStyle/>
+          <a:p>
+            <a:pPr marL="0" lvl="0" indent="0">
+              <a:spcBef>
+                <a:spcPts val="0"/>
+              </a:spcBef>
+              <a:spcAft>
+                <a:spcPts val="0"/>
+              </a:spcAft>
+              <a:buNone/>
+            </a:pPr>
+            <a:fld id="{00000000-1234-1234-1234-123412341234}" type="slidenum">
+              <a:rPr lang="en-GB" smtClean="0"/>
+              <a:t>19</a:t>
+            </a:fld>
+            <a:endParaRPr lang="en-GB"/>
+          </a:p>
+        </p:txBody>
+      </p:sp>
+      <p:graphicFrame>
+        <p:nvGraphicFramePr>
+          <p:cNvPr id="5" name="表格 4">
+            <a:extLst>
+              <a:ext uri="{FF2B5EF4-FFF2-40B4-BE49-F238E27FC236}">
+                <a16:creationId xmlns:a16="http://schemas.microsoft.com/office/drawing/2014/main" id="{D43271BA-3F4A-170E-94DF-1E0D27DD2243}"/>
+              </a:ext>
+            </a:extLst>
+          </p:cNvPr>
+          <p:cNvGraphicFramePr>
+            <a:graphicFrameLocks noGrp="1"/>
+          </p:cNvGraphicFramePr>
+          <p:nvPr>
+            <p:extLst>
+              <p:ext uri="{D42A27DB-BD31-4B8C-83A1-F6EECF244321}">
+                <p14:modId xmlns:p14="http://schemas.microsoft.com/office/powerpoint/2010/main" val="448328936"/>
+              </p:ext>
+            </p:extLst>
+          </p:nvPr>
+        </p:nvGraphicFramePr>
+        <p:xfrm>
+          <a:off x="473814" y="2557042"/>
+          <a:ext cx="4908550" cy="1369730"/>
+        </p:xfrm>
+        <a:graphic>
+          <a:graphicData uri="http://schemas.openxmlformats.org/drawingml/2006/table">
+            <a:tbl>
+              <a:tblPr firstRow="1" bandRow="1">
+                <a:tableStyleId>{5C22544A-7EE6-4342-B048-85BDC9FD1C3A}</a:tableStyleId>
+              </a:tblPr>
+              <a:tblGrid>
+                <a:gridCol w="564249">
+                  <a:extLst>
+                    <a:ext uri="{9D8B030D-6E8A-4147-A177-3AD203B41FA5}">
+                      <a16:colId xmlns:a16="http://schemas.microsoft.com/office/drawing/2014/main" val="2880815991"/>
+                    </a:ext>
+                  </a:extLst>
+                </a:gridCol>
+                <a:gridCol w="588015">
+                  <a:extLst>
+                    <a:ext uri="{9D8B030D-6E8A-4147-A177-3AD203B41FA5}">
+                      <a16:colId xmlns:a16="http://schemas.microsoft.com/office/drawing/2014/main" val="2359583450"/>
+                    </a:ext>
+                  </a:extLst>
+                </a:gridCol>
+                <a:gridCol w="1794465">
+                  <a:extLst>
+                    <a:ext uri="{9D8B030D-6E8A-4147-A177-3AD203B41FA5}">
+                      <a16:colId xmlns:a16="http://schemas.microsoft.com/office/drawing/2014/main" val="1723290835"/>
+                    </a:ext>
+                  </a:extLst>
+                </a:gridCol>
+                <a:gridCol w="1961821">
+                  <a:extLst>
+                    <a:ext uri="{9D8B030D-6E8A-4147-A177-3AD203B41FA5}">
+                      <a16:colId xmlns:a16="http://schemas.microsoft.com/office/drawing/2014/main" val="3499442225"/>
+                    </a:ext>
+                  </a:extLst>
+                </a:gridCol>
+              </a:tblGrid>
+              <a:tr h="273946">
+                <a:tc>
+                  <a:txBody>
+                    <a:bodyPr/>
+                    <a:lstStyle/>
+                    <a:p>
+                      <a:pPr algn="ctr"/>
+                      <a:r>
+                        <a:rPr lang="en-US" altLang="zh-CN" sz="1100"/>
+                        <a:t>S1</a:t>
+                      </a:r>
+                      <a:endParaRPr lang="zh-CN" altLang="en-US" sz="1100"/>
+                    </a:p>
+                  </a:txBody>
+                  <a:tcPr/>
+                </a:tc>
+                <a:tc>
+                  <a:txBody>
+                    <a:bodyPr/>
+                    <a:lstStyle/>
+                    <a:p>
+                      <a:pPr algn="ctr"/>
+                      <a:r>
+                        <a:rPr lang="en-US" altLang="zh-CN" sz="1100"/>
+                        <a:t>S0</a:t>
+                      </a:r>
+                      <a:endParaRPr lang="zh-CN" altLang="en-US" sz="1100"/>
+                    </a:p>
+                  </a:txBody>
+                  <a:tcPr/>
+                </a:tc>
+                <a:tc>
+                  <a:txBody>
+                    <a:bodyPr/>
+                    <a:lstStyle/>
+                    <a:p>
+                      <a:pPr algn="ctr"/>
+                      <a:r>
+                        <a:rPr lang="en-US" altLang="zh-CN" sz="1100"/>
+                        <a:t>S1S0</a:t>
+                      </a:r>
+                      <a:r>
+                        <a:rPr lang="zh-CN" altLang="en-US" sz="1100"/>
+                        <a:t>用</a:t>
+                      </a:r>
+                      <a:r>
+                        <a:rPr lang="en-US" altLang="zh-CN" sz="1100"/>
+                        <a:t>And</a:t>
+                      </a:r>
+                      <a:r>
+                        <a:rPr lang="zh-CN" altLang="en-US" sz="1100"/>
+                        <a:t>组合成</a:t>
+                      </a:r>
+                      <a:r>
+                        <a:rPr lang="en-US" altLang="zh-CN" sz="1100"/>
+                        <a:t>b</a:t>
+                      </a:r>
+                      <a:r>
+                        <a:rPr lang="zh-CN" altLang="en-US" sz="1100"/>
+                        <a:t>信号</a:t>
+                      </a:r>
+                    </a:p>
+                  </a:txBody>
+                  <a:tcPr/>
+                </a:tc>
+                <a:tc>
+                  <a:txBody>
+                    <a:bodyPr/>
+                    <a:lstStyle/>
+                    <a:p>
+                      <a:pPr algn="ctr"/>
+                      <a:r>
+                        <a:rPr lang="zh-CN" altLang="en-US" sz="1100"/>
+                        <a:t>接哪个</a:t>
+                      </a:r>
+                      <a:r>
+                        <a:rPr lang="en-US" altLang="zh-CN" sz="1100"/>
+                        <a:t>And</a:t>
+                      </a:r>
+                      <a:r>
+                        <a:rPr lang="zh-CN" altLang="en-US" sz="1100"/>
+                        <a:t>门的</a:t>
+                      </a:r>
+                      <a:r>
+                        <a:rPr lang="en-US" altLang="zh-CN" sz="1100"/>
+                        <a:t>b</a:t>
+                      </a:r>
+                      <a:r>
+                        <a:rPr lang="zh-CN" altLang="en-US" sz="1100"/>
+                        <a:t>信号</a:t>
+                      </a:r>
+                    </a:p>
+                  </a:txBody>
+                  <a:tcPr/>
+                </a:tc>
+                <a:extLst>
+                  <a:ext uri="{0D108BD9-81ED-4DB2-BD59-A6C34878D82A}">
+                    <a16:rowId xmlns:a16="http://schemas.microsoft.com/office/drawing/2014/main" val="4232458990"/>
+                  </a:ext>
+                </a:extLst>
+              </a:tr>
+              <a:tr h="273946">
+                <a:tc>
+                  <a:txBody>
+                    <a:bodyPr/>
+                    <a:lstStyle/>
+                    <a:p>
+                      <a:pPr algn="ctr"/>
+                      <a:r>
+                        <a:rPr lang="en-US" altLang="zh-CN" sz="1100"/>
+                        <a:t>0</a:t>
+                      </a:r>
+                      <a:endParaRPr lang="zh-CN" altLang="en-US" sz="1100"/>
+                    </a:p>
+                  </a:txBody>
+                  <a:tcPr/>
+                </a:tc>
+                <a:tc>
+                  <a:txBody>
+                    <a:bodyPr/>
+                    <a:lstStyle/>
+                    <a:p>
+                      <a:pPr algn="ctr"/>
+                      <a:r>
+                        <a:rPr lang="en-US" altLang="zh-CN" sz="1100"/>
+                        <a:t>0</a:t>
+                      </a:r>
+                      <a:endParaRPr lang="zh-CN" altLang="en-US" sz="1100"/>
+                    </a:p>
+                  </a:txBody>
+                  <a:tcPr/>
+                </a:tc>
+                <a:tc>
+                  <a:txBody>
+                    <a:bodyPr/>
+                    <a:lstStyle/>
+                    <a:p>
+                      <a:pPr algn="ctr"/>
+                      <a:r>
+                        <a:rPr lang="en-US" altLang="zh-CN" sz="1100"/>
+                        <a:t>S1S0</a:t>
+                      </a:r>
+                      <a:endParaRPr lang="zh-CN" altLang="en-US" sz="1100"/>
+                    </a:p>
+                  </a:txBody>
+                  <a:tcPr/>
+                </a:tc>
+                <a:tc>
+                  <a:txBody>
+                    <a:bodyPr/>
+                    <a:lstStyle/>
+                    <a:p>
+                      <a:pPr algn="ctr"/>
+                      <a:r>
+                        <a:rPr lang="en-US" altLang="zh-CN" sz="1100"/>
+                        <a:t>A</a:t>
+                      </a:r>
+                      <a:endParaRPr lang="zh-CN" altLang="en-US" sz="1100"/>
+                    </a:p>
+                  </a:txBody>
+                  <a:tcPr/>
+                </a:tc>
+                <a:extLst>
+                  <a:ext uri="{0D108BD9-81ED-4DB2-BD59-A6C34878D82A}">
+                    <a16:rowId xmlns:a16="http://schemas.microsoft.com/office/drawing/2014/main" val="3401603527"/>
+                  </a:ext>
+                </a:extLst>
+              </a:tr>
+              <a:tr h="273946">
+                <a:tc>
+                  <a:txBody>
+                    <a:bodyPr/>
+                    <a:lstStyle/>
+                    <a:p>
+                      <a:pPr algn="ctr"/>
+                      <a:r>
+                        <a:rPr lang="en-US" altLang="zh-CN" sz="1100"/>
+                        <a:t>0</a:t>
+                      </a:r>
+                      <a:endParaRPr lang="zh-CN" altLang="en-US" sz="1100"/>
+                    </a:p>
+                  </a:txBody>
+                  <a:tcPr/>
+                </a:tc>
+                <a:tc>
+                  <a:txBody>
+                    <a:bodyPr/>
+                    <a:lstStyle/>
+                    <a:p>
+                      <a:pPr algn="ctr"/>
+                      <a:r>
+                        <a:rPr lang="en-US" altLang="zh-CN" sz="1100"/>
+                        <a:t>1</a:t>
+                      </a:r>
+                      <a:endParaRPr lang="zh-CN" altLang="en-US" sz="1100"/>
+                    </a:p>
+                  </a:txBody>
+                  <a:tcPr/>
+                </a:tc>
+                <a:tc>
+                  <a:txBody>
+                    <a:bodyPr/>
+                    <a:lstStyle/>
+                    <a:p>
+                      <a:pPr marL="0" marR="0" lvl="0" indent="0" algn="ctr" defTabSz="914400" rtl="0" eaLnBrk="1" fontAlgn="auto" latinLnBrk="0" hangingPunct="1">
+                        <a:lnSpc>
+                          <a:spcPct val="100000"/>
+                        </a:lnSpc>
+                        <a:spcBef>
+                          <a:spcPts val="0"/>
+                        </a:spcBef>
+                        <a:spcAft>
+                          <a:spcPts val="0"/>
+                        </a:spcAft>
+                        <a:buClr>
+                          <a:srgbClr val="000000"/>
+                        </a:buClr>
+                        <a:buSzTx/>
+                        <a:buFont typeface="Arial"/>
+                        <a:buNone/>
+                        <a:tabLst/>
+                        <a:defRPr/>
+                      </a:pPr>
+                      <a:r>
+                        <a:rPr lang="en-US" altLang="zh-CN" sz="1100"/>
+                        <a:t>S1S0</a:t>
+                      </a:r>
+                      <a:endParaRPr lang="zh-CN" altLang="en-US" sz="1100"/>
+                    </a:p>
+                  </a:txBody>
+                  <a:tcPr/>
+                </a:tc>
+                <a:tc>
+                  <a:txBody>
+                    <a:bodyPr/>
+                    <a:lstStyle/>
+                    <a:p>
+                      <a:pPr algn="ctr"/>
+                      <a:r>
+                        <a:rPr lang="en-US" altLang="zh-CN" sz="1100"/>
+                        <a:t>B</a:t>
+                      </a:r>
+                      <a:endParaRPr lang="zh-CN" altLang="en-US" sz="1100"/>
+                    </a:p>
+                  </a:txBody>
+                  <a:tcPr/>
+                </a:tc>
+                <a:extLst>
+                  <a:ext uri="{0D108BD9-81ED-4DB2-BD59-A6C34878D82A}">
+                    <a16:rowId xmlns:a16="http://schemas.microsoft.com/office/drawing/2014/main" val="2420810354"/>
+                  </a:ext>
+                </a:extLst>
+              </a:tr>
+              <a:tr h="273946">
+                <a:tc>
+                  <a:txBody>
+                    <a:bodyPr/>
+                    <a:lstStyle/>
+                    <a:p>
+                      <a:pPr algn="ctr"/>
+                      <a:r>
+                        <a:rPr lang="en-US" altLang="zh-CN" sz="1100"/>
+                        <a:t>1</a:t>
+                      </a:r>
+                      <a:endParaRPr lang="zh-CN" altLang="en-US" sz="1100"/>
+                    </a:p>
+                  </a:txBody>
+                  <a:tcPr/>
+                </a:tc>
+                <a:tc>
+                  <a:txBody>
+                    <a:bodyPr/>
+                    <a:lstStyle/>
+                    <a:p>
+                      <a:pPr algn="ctr"/>
+                      <a:r>
+                        <a:rPr lang="en-US" altLang="zh-CN" sz="1100"/>
+                        <a:t>0</a:t>
+                      </a:r>
+                      <a:endParaRPr lang="zh-CN" altLang="en-US" sz="1100"/>
+                    </a:p>
+                  </a:txBody>
+                  <a:tcPr/>
+                </a:tc>
+                <a:tc>
+                  <a:txBody>
+                    <a:bodyPr/>
+                    <a:lstStyle/>
+                    <a:p>
+                      <a:pPr marL="0" marR="0" lvl="0" indent="0" algn="ctr" defTabSz="914400" rtl="0" eaLnBrk="1" fontAlgn="auto" latinLnBrk="0" hangingPunct="1">
+                        <a:lnSpc>
+                          <a:spcPct val="100000"/>
+                        </a:lnSpc>
+                        <a:spcBef>
+                          <a:spcPts val="0"/>
+                        </a:spcBef>
+                        <a:spcAft>
+                          <a:spcPts val="0"/>
+                        </a:spcAft>
+                        <a:buClr>
+                          <a:srgbClr val="000000"/>
+                        </a:buClr>
+                        <a:buSzTx/>
+                        <a:buFont typeface="Arial"/>
+                        <a:buNone/>
+                        <a:tabLst/>
+                        <a:defRPr/>
+                      </a:pPr>
+                      <a:r>
+                        <a:rPr lang="en-US" altLang="zh-CN" sz="1100"/>
+                        <a:t>S1S0</a:t>
+                      </a:r>
+                      <a:endParaRPr lang="zh-CN" altLang="en-US" sz="1100"/>
+                    </a:p>
+                  </a:txBody>
+                  <a:tcPr/>
+                </a:tc>
+                <a:tc>
+                  <a:txBody>
+                    <a:bodyPr/>
+                    <a:lstStyle/>
+                    <a:p>
+                      <a:pPr algn="ctr"/>
+                      <a:r>
+                        <a:rPr lang="en-US" altLang="zh-CN" sz="1100"/>
+                        <a:t>C</a:t>
+                      </a:r>
+                      <a:endParaRPr lang="zh-CN" altLang="en-US" sz="1100"/>
+                    </a:p>
+                  </a:txBody>
+                  <a:tcPr/>
+                </a:tc>
+                <a:extLst>
+                  <a:ext uri="{0D108BD9-81ED-4DB2-BD59-A6C34878D82A}">
+                    <a16:rowId xmlns:a16="http://schemas.microsoft.com/office/drawing/2014/main" val="2711586362"/>
+                  </a:ext>
+                </a:extLst>
+              </a:tr>
+              <a:tr h="273946">
+                <a:tc>
+                  <a:txBody>
+                    <a:bodyPr/>
+                    <a:lstStyle/>
+                    <a:p>
+                      <a:pPr algn="ctr"/>
+                      <a:r>
+                        <a:rPr lang="en-US" altLang="zh-CN" sz="1100"/>
+                        <a:t>1</a:t>
+                      </a:r>
+                      <a:endParaRPr lang="zh-CN" altLang="en-US" sz="1100"/>
+                    </a:p>
+                  </a:txBody>
+                  <a:tcPr/>
+                </a:tc>
+                <a:tc>
+                  <a:txBody>
+                    <a:bodyPr/>
+                    <a:lstStyle/>
+                    <a:p>
+                      <a:pPr algn="ctr"/>
+                      <a:r>
+                        <a:rPr lang="en-US" altLang="zh-CN" sz="1100"/>
+                        <a:t>1</a:t>
+                      </a:r>
+                      <a:endParaRPr lang="zh-CN" altLang="en-US" sz="1100"/>
+                    </a:p>
+                  </a:txBody>
+                  <a:tcPr/>
+                </a:tc>
+                <a:tc>
+                  <a:txBody>
+                    <a:bodyPr/>
+                    <a:lstStyle/>
+                    <a:p>
+                      <a:pPr marL="0" marR="0" lvl="0" indent="0" algn="ctr" defTabSz="914400" rtl="0" eaLnBrk="1" fontAlgn="auto" latinLnBrk="0" hangingPunct="1">
+                        <a:lnSpc>
+                          <a:spcPct val="100000"/>
+                        </a:lnSpc>
+                        <a:spcBef>
+                          <a:spcPts val="0"/>
+                        </a:spcBef>
+                        <a:spcAft>
+                          <a:spcPts val="0"/>
+                        </a:spcAft>
+                        <a:buClr>
+                          <a:srgbClr val="000000"/>
+                        </a:buClr>
+                        <a:buSzTx/>
+                        <a:buFont typeface="Arial"/>
+                        <a:buNone/>
+                        <a:tabLst/>
+                        <a:defRPr/>
+                      </a:pPr>
+                      <a:r>
+                        <a:rPr lang="en-US" altLang="zh-CN" sz="1100"/>
+                        <a:t>S1S0</a:t>
+                      </a:r>
+                      <a:endParaRPr lang="zh-CN" altLang="en-US" sz="1100"/>
+                    </a:p>
+                  </a:txBody>
+                  <a:tcPr/>
+                </a:tc>
+                <a:tc>
+                  <a:txBody>
+                    <a:bodyPr/>
+                    <a:lstStyle/>
+                    <a:p>
+                      <a:pPr algn="ctr"/>
+                      <a:r>
+                        <a:rPr lang="en-US" altLang="zh-CN" sz="1100"/>
+                        <a:t>D</a:t>
+                      </a:r>
+                      <a:endParaRPr lang="zh-CN" altLang="en-US" sz="1100"/>
+                    </a:p>
+                  </a:txBody>
+                  <a:tcPr/>
+                </a:tc>
+                <a:extLst>
+                  <a:ext uri="{0D108BD9-81ED-4DB2-BD59-A6C34878D82A}">
+                    <a16:rowId xmlns:a16="http://schemas.microsoft.com/office/drawing/2014/main" val="2533759617"/>
+                  </a:ext>
+                </a:extLst>
+              </a:tr>
+            </a:tbl>
+          </a:graphicData>
+        </a:graphic>
+      </p:graphicFrame>
+      <p:cxnSp>
+        <p:nvCxnSpPr>
+          <p:cNvPr id="7" name="直接连接符 6">
+            <a:extLst>
+              <a:ext uri="{FF2B5EF4-FFF2-40B4-BE49-F238E27FC236}">
+                <a16:creationId xmlns:a16="http://schemas.microsoft.com/office/drawing/2014/main" id="{1F0F0A6F-4AB2-7A33-D1E9-FB483E8B0CA4}"/>
+              </a:ext>
+            </a:extLst>
+          </p:cNvPr>
+          <p:cNvCxnSpPr>
+            <a:cxnSpLocks/>
+          </p:cNvCxnSpPr>
+          <p:nvPr/>
+        </p:nvCxnSpPr>
+        <p:spPr>
+          <a:xfrm>
+            <a:off x="2356480" y="2873005"/>
+            <a:ext cx="155203" cy="0"/>
+          </a:xfrm>
+          <a:prstGeom prst="line">
+            <a:avLst/>
+          </a:prstGeom>
+        </p:spPr>
+        <p:style>
+          <a:lnRef idx="1">
+            <a:schemeClr val="dk1"/>
+          </a:lnRef>
+          <a:fillRef idx="0">
+            <a:schemeClr val="dk1"/>
+          </a:fillRef>
+          <a:effectRef idx="0">
+            <a:schemeClr val="dk1"/>
+          </a:effectRef>
+          <a:fontRef idx="minor">
+            <a:schemeClr val="tx1"/>
+          </a:fontRef>
+        </p:style>
+      </p:cxnSp>
+      <p:cxnSp>
+        <p:nvCxnSpPr>
+          <p:cNvPr id="9" name="直接连接符 8">
+            <a:extLst>
+              <a:ext uri="{FF2B5EF4-FFF2-40B4-BE49-F238E27FC236}">
+                <a16:creationId xmlns:a16="http://schemas.microsoft.com/office/drawing/2014/main" id="{2EB877DE-18A6-EF52-90D0-18B1562AC55E}"/>
+              </a:ext>
+            </a:extLst>
+          </p:cNvPr>
+          <p:cNvCxnSpPr>
+            <a:cxnSpLocks/>
+          </p:cNvCxnSpPr>
+          <p:nvPr/>
+        </p:nvCxnSpPr>
+        <p:spPr>
+          <a:xfrm>
+            <a:off x="2532698" y="2873005"/>
+            <a:ext cx="155203" cy="0"/>
+          </a:xfrm>
+          <a:prstGeom prst="line">
+            <a:avLst/>
+          </a:prstGeom>
+        </p:spPr>
+        <p:style>
+          <a:lnRef idx="1">
+            <a:schemeClr val="dk1"/>
+          </a:lnRef>
+          <a:fillRef idx="0">
+            <a:schemeClr val="dk1"/>
+          </a:fillRef>
+          <a:effectRef idx="0">
+            <a:schemeClr val="dk1"/>
+          </a:effectRef>
+          <a:fontRef idx="minor">
+            <a:schemeClr val="tx1"/>
+          </a:fontRef>
+        </p:style>
+      </p:cxnSp>
+      <p:cxnSp>
+        <p:nvCxnSpPr>
+          <p:cNvPr id="10" name="直接连接符 9">
+            <a:extLst>
+              <a:ext uri="{FF2B5EF4-FFF2-40B4-BE49-F238E27FC236}">
+                <a16:creationId xmlns:a16="http://schemas.microsoft.com/office/drawing/2014/main" id="{68C5F977-75C0-BC98-BA2B-B6B5C518766C}"/>
+              </a:ext>
+            </a:extLst>
+          </p:cNvPr>
+          <p:cNvCxnSpPr>
+            <a:cxnSpLocks/>
+          </p:cNvCxnSpPr>
+          <p:nvPr/>
+        </p:nvCxnSpPr>
+        <p:spPr>
+          <a:xfrm>
+            <a:off x="2352035" y="3142881"/>
+            <a:ext cx="155203" cy="0"/>
+          </a:xfrm>
+          <a:prstGeom prst="line">
+            <a:avLst/>
+          </a:prstGeom>
+        </p:spPr>
+        <p:style>
+          <a:lnRef idx="1">
+            <a:schemeClr val="dk1"/>
+          </a:lnRef>
+          <a:fillRef idx="0">
+            <a:schemeClr val="dk1"/>
+          </a:fillRef>
+          <a:effectRef idx="0">
+            <a:schemeClr val="dk1"/>
+          </a:effectRef>
+          <a:fontRef idx="minor">
+            <a:schemeClr val="tx1"/>
+          </a:fontRef>
+        </p:style>
+      </p:cxnSp>
+      <p:cxnSp>
+        <p:nvCxnSpPr>
+          <p:cNvPr id="11" name="直接连接符 10">
+            <a:extLst>
+              <a:ext uri="{FF2B5EF4-FFF2-40B4-BE49-F238E27FC236}">
+                <a16:creationId xmlns:a16="http://schemas.microsoft.com/office/drawing/2014/main" id="{F9A1493A-CB68-02D9-C373-A97945413FB1}"/>
+              </a:ext>
+            </a:extLst>
+          </p:cNvPr>
+          <p:cNvCxnSpPr>
+            <a:cxnSpLocks/>
+          </p:cNvCxnSpPr>
+          <p:nvPr/>
+        </p:nvCxnSpPr>
+        <p:spPr>
+          <a:xfrm>
+            <a:off x="2502530" y="3428313"/>
+            <a:ext cx="155203" cy="0"/>
+          </a:xfrm>
+          <a:prstGeom prst="line">
+            <a:avLst/>
+          </a:prstGeom>
+        </p:spPr>
+        <p:style>
+          <a:lnRef idx="1">
+            <a:schemeClr val="dk1"/>
+          </a:lnRef>
+          <a:fillRef idx="0">
+            <a:schemeClr val="dk1"/>
+          </a:fillRef>
+          <a:effectRef idx="0">
+            <a:schemeClr val="dk1"/>
+          </a:effectRef>
+          <a:fontRef idx="minor">
+            <a:schemeClr val="tx1"/>
+          </a:fontRef>
+        </p:style>
+      </p:cxnSp>
+      <p:pic>
+        <p:nvPicPr>
+          <p:cNvPr id="15" name="图片 14">
+            <a:extLst>
+              <a:ext uri="{FF2B5EF4-FFF2-40B4-BE49-F238E27FC236}">
+                <a16:creationId xmlns:a16="http://schemas.microsoft.com/office/drawing/2014/main" id="{F96F7213-4D54-D259-D0C7-646B97159D90}"/>
+              </a:ext>
+            </a:extLst>
+          </p:cNvPr>
+          <p:cNvPicPr>
+            <a:picLocks noChangeAspect="1"/>
+          </p:cNvPicPr>
+          <p:nvPr/>
+        </p:nvPicPr>
+        <p:blipFill>
+          <a:blip r:embed="rId3"/>
+          <a:stretch>
+            <a:fillRect/>
+          </a:stretch>
+        </p:blipFill>
+        <p:spPr>
+          <a:xfrm>
+            <a:off x="5631180" y="1216728"/>
+            <a:ext cx="3390312" cy="2882240"/>
+          </a:xfrm>
+          <a:prstGeom prst="rect">
+            <a:avLst/>
+          </a:prstGeom>
+        </p:spPr>
+      </p:pic>
+    </p:spTree>
+    <p:extLst>
+      <p:ext uri="{BB962C8B-B14F-4D97-AF65-F5344CB8AC3E}">
+        <p14:creationId xmlns:p14="http://schemas.microsoft.com/office/powerpoint/2010/main" val="3026495264"/>
+      </p:ext>
+    </p:extLst>
+  </p:cSld>
+  <p:clrMapOvr>
+    <a:masterClrMapping/>
+  </p:clrMapOvr>
+</p:sld>
+</file>
+
+<file path=ppt/slides/slide2.xml><?xml version="1.0" encoding="utf-8"?>
+<p:sld xmlns:a="http://schemas.openxmlformats.org/drawingml/2006/main" xmlns:r="http://schemas.openxmlformats.org/officeDocument/2006/relationships" xmlns:p="http://schemas.openxmlformats.org/presentationml/2006/main">
+  <p:cSld>
+    <p:spTree>
+      <p:nvGrpSpPr>
+        <p:cNvPr id="1" name=""/>
+        <p:cNvGrpSpPr/>
+        <p:nvPr/>
+      </p:nvGrpSpPr>
+      <p:grpSpPr>
+        <a:xfrm>
+          <a:off x="0" y="0"/>
+          <a:ext cx="0" cy="0"/>
+          <a:chOff x="0" y="0"/>
+          <a:chExt cx="0" cy="0"/>
+        </a:xfrm>
+      </p:grpSpPr>
+      <p:sp>
+        <p:nvSpPr>
+          <p:cNvPr id="2" name="Title 1">
+            <a:extLst>
+              <a:ext uri="{FF2B5EF4-FFF2-40B4-BE49-F238E27FC236}">
+                <a16:creationId xmlns:a16="http://schemas.microsoft.com/office/drawing/2014/main" id="{AF882870-0C4A-010E-A508-17DB005AAA94}"/>
+              </a:ext>
+            </a:extLst>
+          </p:cNvPr>
+          <p:cNvSpPr>
+            <a:spLocks noGrp="1"/>
+          </p:cNvSpPr>
+          <p:nvPr>
+            <p:ph type="title"/>
+          </p:nvPr>
+        </p:nvSpPr>
+        <p:spPr/>
+        <p:txBody>
+          <a:bodyPr>
+            <a:noAutofit/>
+          </a:bodyPr>
+          <a:lstStyle/>
+          <a:p>
+            <a:endParaRPr lang="en-US" sz="3600"/>
+          </a:p>
+        </p:txBody>
+      </p:sp>
+      <p:sp>
+        <p:nvSpPr>
+          <p:cNvPr id="3" name="Slide Number Placeholder 2">
+            <a:extLst>
+              <a:ext uri="{FF2B5EF4-FFF2-40B4-BE49-F238E27FC236}">
+                <a16:creationId xmlns:a16="http://schemas.microsoft.com/office/drawing/2014/main" id="{E1D8038A-4B4E-4FDE-88A3-E894F843AB38}"/>
+              </a:ext>
+            </a:extLst>
+          </p:cNvPr>
+          <p:cNvSpPr>
+            <a:spLocks noGrp="1"/>
+          </p:cNvSpPr>
+          <p:nvPr>
+            <p:ph type="sldNum" sz="quarter" idx="12"/>
+          </p:nvPr>
+        </p:nvSpPr>
+        <p:spPr/>
+        <p:txBody>
+          <a:bodyPr/>
+          <a:lstStyle/>
+          <a:p>
+            <a:fld id="{9D4AD3D6-B89C-4D82-B254-B84B3D342745}" type="slidenum">
+              <a:rPr lang="en-FI" smtClean="0"/>
+              <a:t>2</a:t>
+            </a:fld>
+            <a:endParaRPr lang="en-FI"/>
+          </a:p>
+        </p:txBody>
+      </p:sp>
+      <p:sp>
+        <p:nvSpPr>
+          <p:cNvPr id="5" name="TextBox 4">
+            <a:extLst>
+              <a:ext uri="{FF2B5EF4-FFF2-40B4-BE49-F238E27FC236}">
+                <a16:creationId xmlns:a16="http://schemas.microsoft.com/office/drawing/2014/main" id="{F220711D-C0C1-1E6C-6C31-D879DEA0EC3A}"/>
+              </a:ext>
+            </a:extLst>
+          </p:cNvPr>
+          <p:cNvSpPr txBox="1"/>
+          <p:nvPr/>
+        </p:nvSpPr>
+        <p:spPr>
+          <a:xfrm>
+            <a:off x="352235" y="276495"/>
+            <a:ext cx="3759362" cy="584775"/>
+          </a:xfrm>
+          <a:prstGeom prst="rect">
+            <a:avLst/>
+          </a:prstGeom>
+          <a:noFill/>
+        </p:spPr>
+        <p:txBody>
+          <a:bodyPr wrap="none" rtlCol="0">
+            <a:spAutoFit/>
+          </a:bodyPr>
+          <a:lstStyle/>
+          <a:p>
+            <a:r>
+              <a:rPr lang="en-US" sz="3200"/>
+              <a:t>Learning Outcomes</a:t>
+            </a:r>
+          </a:p>
+        </p:txBody>
+      </p:sp>
+      <p:sp>
+        <p:nvSpPr>
+          <p:cNvPr id="7" name="TextBox 6">
+            <a:extLst>
+              <a:ext uri="{FF2B5EF4-FFF2-40B4-BE49-F238E27FC236}">
+                <a16:creationId xmlns:a16="http://schemas.microsoft.com/office/drawing/2014/main" id="{9C697D06-B38C-C793-DF76-81D494BE6D9C}"/>
+              </a:ext>
+            </a:extLst>
+          </p:cNvPr>
+          <p:cNvSpPr txBox="1"/>
+          <p:nvPr/>
+        </p:nvSpPr>
+        <p:spPr>
+          <a:xfrm>
+            <a:off x="476545" y="1266605"/>
+            <a:ext cx="8460940" cy="2154436"/>
+          </a:xfrm>
+          <a:prstGeom prst="rect">
+            <a:avLst/>
+          </a:prstGeom>
+          <a:noFill/>
+        </p:spPr>
+        <p:txBody>
+          <a:bodyPr wrap="square" rtlCol="0">
+            <a:spAutoFit/>
+          </a:bodyPr>
+          <a:lstStyle/>
+          <a:p>
+            <a:pPr marL="285750" indent="-285750">
+              <a:buFont typeface="Arial" panose="020B0604020202020204" pitchFamily="34" charset="0"/>
+              <a:buChar char="•"/>
+            </a:pPr>
+            <a:r>
+              <a:rPr lang="en-US" sz="2000" err="1"/>
+              <a:t>Analyse</a:t>
+            </a:r>
+            <a:r>
+              <a:rPr lang="en-US" sz="2000"/>
+              <a:t> and design a combinational logic circuit</a:t>
+            </a:r>
+          </a:p>
+          <a:p>
+            <a:pPr marL="285750" indent="-285750">
+              <a:buFont typeface="Arial" panose="020B0604020202020204" pitchFamily="34" charset="0"/>
+              <a:buChar char="•"/>
+            </a:pPr>
+            <a:endParaRPr lang="en-US" sz="2000"/>
+          </a:p>
+          <a:p>
+            <a:pPr marL="285750" indent="-285750">
+              <a:buFont typeface="Arial" panose="020B0604020202020204" pitchFamily="34" charset="0"/>
+              <a:buChar char="•"/>
+            </a:pPr>
+            <a:r>
+              <a:rPr lang="en-US" sz="2000"/>
+              <a:t>Utilize a hardware simulator to design, test, and analyze the behavior of a digital circuit</a:t>
+            </a:r>
+          </a:p>
+          <a:p>
+            <a:pPr marL="285750" indent="-285750">
+              <a:buFont typeface="Arial" panose="020B0604020202020204" pitchFamily="34" charset="0"/>
+              <a:buChar char="•"/>
+            </a:pPr>
+            <a:endParaRPr lang="en-US" sz="2000"/>
+          </a:p>
+          <a:p>
+            <a:pPr marL="285750" indent="-285750">
+              <a:buFont typeface="Arial" panose="020B0604020202020204" pitchFamily="34" charset="0"/>
+              <a:buChar char="•"/>
+            </a:pPr>
+            <a:r>
+              <a:rPr lang="en-US" sz="2000"/>
+              <a:t>Implement and debug combinational logic circuits using HDL </a:t>
+            </a:r>
+          </a:p>
+          <a:p>
+            <a:endParaRPr lang="en-US"/>
+          </a:p>
+        </p:txBody>
+      </p:sp>
+    </p:spTree>
+    <p:extLst>
+      <p:ext uri="{BB962C8B-B14F-4D97-AF65-F5344CB8AC3E}">
+        <p14:creationId xmlns:p14="http://schemas.microsoft.com/office/powerpoint/2010/main" val="166172910"/>
+      </p:ext>
+    </p:extLst>
+  </p:cSld>
+  <p:clrMapOvr>
+    <a:masterClrMapping/>
+  </p:clrMapOvr>
+</p:sld>
+</file>
+
+<file path=ppt/slides/slide20.xml><?xml version="1.0" encoding="utf-8"?>
+<p:sld xmlns:a="http://schemas.openxmlformats.org/drawingml/2006/main" xmlns:r="http://schemas.openxmlformats.org/officeDocument/2006/relationships" xmlns:p="http://schemas.openxmlformats.org/presentationml/2006/main">
+  <p:cSld>
+    <p:spTree>
+      <p:nvGrpSpPr>
         <p:cNvPr id="1" name="">
           <a:extLst>
             <a:ext uri="{FF2B5EF4-FFF2-40B4-BE49-F238E27FC236}">
@@ -24795,7 +26391,7 @@
             </a:pPr>
             <a:fld id="{00000000-1234-1234-1234-123412341234}" type="slidenum">
               <a:rPr lang="en-GB" smtClean="0"/>
-              <a:t>19</a:t>
+              <a:t>20</a:t>
             </a:fld>
             <a:endParaRPr lang="en-GB"/>
           </a:p>
@@ -26268,208 +27864,7 @@
 </p:sld>
 </file>
 
-<file path=ppt/slides/slide2.xml><?xml version="1.0" encoding="utf-8"?>
-<p:sld xmlns:a="http://schemas.openxmlformats.org/drawingml/2006/main" xmlns:r="http://schemas.openxmlformats.org/officeDocument/2006/relationships" xmlns:p="http://schemas.openxmlformats.org/presentationml/2006/main">
-  <p:cSld>
-    <p:spTree>
-      <p:nvGrpSpPr>
-        <p:cNvPr id="1" name=""/>
-        <p:cNvGrpSpPr/>
-        <p:nvPr/>
-      </p:nvGrpSpPr>
-      <p:grpSpPr>
-        <a:xfrm>
-          <a:off x="0" y="0"/>
-          <a:ext cx="0" cy="0"/>
-          <a:chOff x="0" y="0"/>
-          <a:chExt cx="0" cy="0"/>
-        </a:xfrm>
-      </p:grpSpPr>
-      <p:sp>
-        <p:nvSpPr>
-          <p:cNvPr id="2" name="Title 1">
-            <a:extLst>
-              <a:ext uri="{FF2B5EF4-FFF2-40B4-BE49-F238E27FC236}">
-                <a16:creationId xmlns:a16="http://schemas.microsoft.com/office/drawing/2014/main" id="{AF882870-0C4A-010E-A508-17DB005AAA94}"/>
-              </a:ext>
-            </a:extLst>
-          </p:cNvPr>
-          <p:cNvSpPr>
-            <a:spLocks noGrp="1"/>
-          </p:cNvSpPr>
-          <p:nvPr>
-            <p:ph type="title"/>
-          </p:nvPr>
-        </p:nvSpPr>
-        <p:spPr/>
-        <p:txBody>
-          <a:bodyPr>
-            <a:noAutofit/>
-          </a:bodyPr>
-          <a:lstStyle/>
-          <a:p>
-            <a:endParaRPr lang="en-US" sz="3600"/>
-          </a:p>
-        </p:txBody>
-      </p:sp>
-      <p:sp>
-        <p:nvSpPr>
-          <p:cNvPr id="3" name="Slide Number Placeholder 2">
-            <a:extLst>
-              <a:ext uri="{FF2B5EF4-FFF2-40B4-BE49-F238E27FC236}">
-                <a16:creationId xmlns:a16="http://schemas.microsoft.com/office/drawing/2014/main" id="{E1D8038A-4B4E-4FDE-88A3-E894F843AB38}"/>
-              </a:ext>
-            </a:extLst>
-          </p:cNvPr>
-          <p:cNvSpPr>
-            <a:spLocks noGrp="1"/>
-          </p:cNvSpPr>
-          <p:nvPr>
-            <p:ph type="sldNum" sz="quarter" idx="12"/>
-          </p:nvPr>
-        </p:nvSpPr>
-        <p:spPr/>
-        <p:txBody>
-          <a:bodyPr/>
-          <a:lstStyle/>
-          <a:p>
-            <a:fld id="{9D4AD3D6-B89C-4D82-B254-B84B3D342745}" type="slidenum">
-              <a:rPr lang="en-FI" smtClean="0"/>
-              <a:t>2</a:t>
-            </a:fld>
-            <a:endParaRPr lang="en-FI"/>
-          </a:p>
-        </p:txBody>
-      </p:sp>
-      <p:sp>
-        <p:nvSpPr>
-          <p:cNvPr id="5" name="TextBox 4">
-            <a:extLst>
-              <a:ext uri="{FF2B5EF4-FFF2-40B4-BE49-F238E27FC236}">
-                <a16:creationId xmlns:a16="http://schemas.microsoft.com/office/drawing/2014/main" id="{F220711D-C0C1-1E6C-6C31-D879DEA0EC3A}"/>
-              </a:ext>
-            </a:extLst>
-          </p:cNvPr>
-          <p:cNvSpPr txBox="1"/>
-          <p:nvPr/>
-        </p:nvSpPr>
-        <p:spPr>
-          <a:xfrm>
-            <a:off x="352235" y="276495"/>
-            <a:ext cx="3759362" cy="584775"/>
-          </a:xfrm>
-          <a:prstGeom prst="rect">
-            <a:avLst/>
-          </a:prstGeom>
-          <a:noFill/>
-        </p:spPr>
-        <p:txBody>
-          <a:bodyPr wrap="none" rtlCol="0">
-            <a:spAutoFit/>
-          </a:bodyPr>
-          <a:lstStyle/>
-          <a:p>
-            <a:r>
-              <a:rPr lang="en-US" sz="3200"/>
-              <a:t>Learning Outcomes</a:t>
-            </a:r>
-          </a:p>
-        </p:txBody>
-      </p:sp>
-      <p:sp>
-        <p:nvSpPr>
-          <p:cNvPr id="7" name="TextBox 6">
-            <a:extLst>
-              <a:ext uri="{FF2B5EF4-FFF2-40B4-BE49-F238E27FC236}">
-                <a16:creationId xmlns:a16="http://schemas.microsoft.com/office/drawing/2014/main" id="{9C697D06-B38C-C793-DF76-81D494BE6D9C}"/>
-              </a:ext>
-            </a:extLst>
-          </p:cNvPr>
-          <p:cNvSpPr txBox="1"/>
-          <p:nvPr/>
-        </p:nvSpPr>
-        <p:spPr>
-          <a:xfrm>
-            <a:off x="476545" y="1266605"/>
-            <a:ext cx="8460940" cy="2154436"/>
-          </a:xfrm>
-          <a:prstGeom prst="rect">
-            <a:avLst/>
-          </a:prstGeom>
-          <a:noFill/>
-        </p:spPr>
-        <p:txBody>
-          <a:bodyPr wrap="square" rtlCol="0">
-            <a:spAutoFit/>
-          </a:bodyPr>
-          <a:lstStyle/>
-          <a:p>
-            <a:pPr marL="285750" indent="-285750">
-              <a:buFont typeface="Arial" panose="020B0604020202020204" pitchFamily="34" charset="0"/>
-              <a:buChar char="•"/>
-            </a:pPr>
-            <a:r>
-              <a:rPr lang="en-US" sz="2000" err="1"/>
-              <a:t>Analyse</a:t>
-            </a:r>
-            <a:r>
-              <a:rPr lang="en-US" sz="2000"/>
-              <a:t> and design a combinational logic circuit</a:t>
-            </a:r>
-          </a:p>
-          <a:p>
-            <a:pPr marL="285750" indent="-285750">
-              <a:buFont typeface="Arial" panose="020B0604020202020204" pitchFamily="34" charset="0"/>
-              <a:buChar char="•"/>
-            </a:pPr>
-            <a:endParaRPr lang="en-US" sz="2000"/>
-          </a:p>
-          <a:p>
-            <a:pPr marL="285750" indent="-285750">
-              <a:buFont typeface="Arial" panose="020B0604020202020204" pitchFamily="34" charset="0"/>
-              <a:buChar char="•"/>
-            </a:pPr>
-            <a:r>
-              <a:rPr lang="en-US" sz="2000"/>
-              <a:t>Utilize a hardware simulator to design, test, and analyze the behavior of a digital circuit</a:t>
-            </a:r>
-          </a:p>
-          <a:p>
-            <a:pPr marL="285750" indent="-285750">
-              <a:buFont typeface="Arial" panose="020B0604020202020204" pitchFamily="34" charset="0"/>
-              <a:buChar char="•"/>
-            </a:pPr>
-            <a:endParaRPr lang="en-US" sz="2000"/>
-          </a:p>
-          <a:p>
-            <a:pPr marL="285750" indent="-285750">
-              <a:buFont typeface="Arial" panose="020B0604020202020204" pitchFamily="34" charset="0"/>
-              <a:buChar char="•"/>
-            </a:pPr>
-            <a:r>
-              <a:rPr lang="en-US" sz="2000"/>
-              <a:t>Implement and debug combinational logic circuits using HDL </a:t>
-            </a:r>
-          </a:p>
-          <a:p>
-            <a:endParaRPr lang="en-US"/>
-          </a:p>
-        </p:txBody>
-      </p:sp>
-    </p:spTree>
-    <p:extLst>
-      <p:ext uri="{BB962C8B-B14F-4D97-AF65-F5344CB8AC3E}">
-        <p14:creationId xmlns:p14="http://schemas.microsoft.com/office/powerpoint/2010/main" val="166172910"/>
-      </p:ext>
-    </p:extLst>
-  </p:cSld>
-  <p:clrMapOvr>
-    <a:masterClrMapping/>
-  </p:clrMapOvr>
-</p:sld>
-</file>
-
-<file path=ppt/slides/slide20.xml><?xml version="1.0" encoding="utf-8"?>
+<file path=ppt/slides/slide21.xml><?xml version="1.0" encoding="utf-8"?>
 <p:sld xmlns:a="http://schemas.openxmlformats.org/drawingml/2006/main" xmlns:r="http://schemas.openxmlformats.org/officeDocument/2006/relationships" xmlns:p="http://schemas.openxmlformats.org/presentationml/2006/main">
   <p:cSld>
     <p:spTree>
@@ -26552,7 +27947,7 @@
             </a:pPr>
             <a:fld id="{00000000-1234-1234-1234-123412341234}" type="slidenum">
               <a:rPr lang="en-GB" smtClean="0"/>
-              <a:t>20</a:t>
+              <a:t>21</a:t>
             </a:fld>
             <a:endParaRPr lang="en-GB"/>
           </a:p>
@@ -27657,7 +29052,7 @@
 </p:sld>
 </file>
 
-<file path=ppt/slides/slide21.xml><?xml version="1.0" encoding="utf-8"?>
+<file path=ppt/slides/slide22.xml><?xml version="1.0" encoding="utf-8"?>
 <p:sld xmlns:a="http://schemas.openxmlformats.org/drawingml/2006/main" xmlns:r="http://schemas.openxmlformats.org/officeDocument/2006/relationships" xmlns:p="http://schemas.openxmlformats.org/presentationml/2006/main">
   <p:cSld>
     <p:spTree>
@@ -27706,7 +29101,7 @@
             </a:pPr>
             <a:fld id="{00000000-1234-1234-1234-123412341234}" type="slidenum">
               <a:rPr lang="en-GB" smtClean="0"/>
-              <a:t>21</a:t>
+              <a:t>22</a:t>
             </a:fld>
             <a:endParaRPr lang="en-GB"/>
           </a:p>
@@ -29984,7 +31379,7 @@
 </p:sld>
 </file>
 
-<file path=ppt/slides/slide22.xml><?xml version="1.0" encoding="utf-8"?>
+<file path=ppt/slides/slide23.xml><?xml version="1.0" encoding="utf-8"?>
 <p:sld xmlns:a="http://schemas.openxmlformats.org/drawingml/2006/main" xmlns:r="http://schemas.openxmlformats.org/officeDocument/2006/relationships" xmlns:p="http://schemas.openxmlformats.org/presentationml/2006/main">
   <p:cSld>
     <p:spTree>
@@ -30513,7 +31908,7 @@
             </a:pPr>
             <a:fld id="{00000000-1234-1234-1234-123412341234}" type="slidenum">
               <a:rPr lang="en-GB" smtClean="0"/>
-              <a:t>22</a:t>
+              <a:t>23</a:t>
             </a:fld>
             <a:endParaRPr lang="en-GB"/>
           </a:p>
@@ -30722,7 +32117,7 @@
 </p:sld>
 </file>
 
-<file path=ppt/slides/slide23.xml><?xml version="1.0" encoding="utf-8"?>
+<file path=ppt/slides/slide24.xml><?xml version="1.0" encoding="utf-8"?>
 <p:sld xmlns:a="http://schemas.openxmlformats.org/drawingml/2006/main" xmlns:r="http://schemas.openxmlformats.org/officeDocument/2006/relationships" xmlns:p="http://schemas.openxmlformats.org/presentationml/2006/main">
   <p:cSld>
     <p:spTree>
@@ -30777,7 +32172,7 @@
             </a:pPr>
             <a:fld id="{00000000-1234-1234-1234-123412341234}" type="slidenum">
               <a:rPr lang="en-GB" smtClean="0"/>
-              <a:t>23</a:t>
+              <a:t>24</a:t>
             </a:fld>
             <a:endParaRPr lang="en-GB"/>
           </a:p>
@@ -32560,7 +33955,7 @@
 </p:sld>
 </file>
 
-<file path=ppt/slides/slide24.xml><?xml version="1.0" encoding="utf-8"?>
+<file path=ppt/slides/slide25.xml><?xml version="1.0" encoding="utf-8"?>
 <p:sld xmlns:a="http://schemas.openxmlformats.org/drawingml/2006/main" xmlns:r="http://schemas.openxmlformats.org/officeDocument/2006/relationships" xmlns:p="http://schemas.openxmlformats.org/presentationml/2006/main">
   <p:cSld>
     <p:spTree>
@@ -32909,7 +34304,7 @@
             </a:pPr>
             <a:fld id="{00000000-1234-1234-1234-123412341234}" type="slidenum">
               <a:rPr lang="en-GB" smtClean="0"/>
-              <a:t>24</a:t>
+              <a:t>25</a:t>
             </a:fld>
             <a:endParaRPr lang="en-GB"/>
           </a:p>
@@ -33408,7 +34803,1219 @@
 </p:sld>
 </file>
 
-<file path=ppt/slides/slide25.xml><?xml version="1.0" encoding="utf-8"?>
+<file path=ppt/slides/slide26.xml><?xml version="1.0" encoding="utf-8"?>
+<p:sld xmlns:a="http://schemas.openxmlformats.org/drawingml/2006/main" xmlns:r="http://schemas.openxmlformats.org/officeDocument/2006/relationships" xmlns:p="http://schemas.openxmlformats.org/presentationml/2006/main">
+  <p:cSld>
+    <p:spTree>
+      <p:nvGrpSpPr>
+        <p:cNvPr id="1" name="">
+          <a:extLst>
+            <a:ext uri="{FF2B5EF4-FFF2-40B4-BE49-F238E27FC236}">
+              <a16:creationId xmlns:a16="http://schemas.microsoft.com/office/drawing/2014/main" id="{6E866E15-4A9C-4E27-CA46-E86E48E3B8BC}"/>
+            </a:ext>
+          </a:extLst>
+        </p:cNvPr>
+        <p:cNvGrpSpPr/>
+        <p:nvPr/>
+      </p:nvGrpSpPr>
+      <p:grpSpPr>
+        <a:xfrm>
+          <a:off x="0" y="0"/>
+          <a:ext cx="0" cy="0"/>
+          <a:chOff x="0" y="0"/>
+          <a:chExt cx="0" cy="0"/>
+        </a:xfrm>
+      </p:grpSpPr>
+      <p:sp>
+        <p:nvSpPr>
+          <p:cNvPr id="2" name="文本占位符 1">
+            <a:extLst>
+              <a:ext uri="{FF2B5EF4-FFF2-40B4-BE49-F238E27FC236}">
+                <a16:creationId xmlns:a16="http://schemas.microsoft.com/office/drawing/2014/main" id="{D65A7267-D5B7-B591-6A9D-D02A93307F08}"/>
+              </a:ext>
+            </a:extLst>
+          </p:cNvPr>
+          <p:cNvSpPr>
+            <a:spLocks noGrp="1"/>
+          </p:cNvSpPr>
+          <p:nvPr>
+            <p:ph type="body" idx="1"/>
+          </p:nvPr>
+        </p:nvSpPr>
+        <p:spPr>
+          <a:xfrm>
+            <a:off x="339724" y="1045790"/>
+            <a:ext cx="7798435" cy="3846249"/>
+          </a:xfrm>
+        </p:spPr>
+        <p:txBody>
+          <a:bodyPr/>
+          <a:lstStyle/>
+          <a:p>
+            <a:pPr marL="571500" indent="-342900">
+              <a:buAutoNum type="arabicPeriod"/>
+            </a:pPr>
+            <a:r>
+              <a:rPr lang="en-US" altLang="zh-CN" sz="1400"/>
+              <a:t>N</a:t>
+            </a:r>
+            <a:r>
+              <a:rPr lang="zh-CN" altLang="en-US" sz="1400"/>
+              <a:t>路</a:t>
+            </a:r>
+            <a:r>
+              <a:rPr lang="zh-CN" altLang="en-US" sz="1400">
+                <a:solidFill>
+                  <a:schemeClr val="accent2"/>
+                </a:solidFill>
+              </a:rPr>
+              <a:t>输出信号</a:t>
+            </a:r>
+            <a:r>
+              <a:rPr lang="zh-CN" altLang="en-US" sz="1400"/>
+              <a:t>需要</a:t>
+            </a:r>
+            <a:r>
+              <a:rPr lang="en-US" altLang="zh-CN" sz="1400"/>
+              <a:t>N</a:t>
+            </a:r>
+            <a:r>
+              <a:rPr lang="zh-CN" altLang="en-US" sz="1400"/>
+              <a:t>个</a:t>
+            </a:r>
+            <a:r>
+              <a:rPr lang="en-US" altLang="zh-CN" sz="1400"/>
+              <a:t>And</a:t>
+            </a:r>
+            <a:r>
+              <a:rPr lang="zh-CN" altLang="en-US" sz="1400"/>
+              <a:t>门（</a:t>
+            </a:r>
+            <a:r>
+              <a:rPr lang="en-US" altLang="zh-CN" sz="1400"/>
+              <a:t>MUX</a:t>
+            </a:r>
+            <a:r>
+              <a:rPr lang="zh-CN" altLang="en-US" sz="1400"/>
+              <a:t>是看输入信号）</a:t>
+            </a:r>
+            <a:endParaRPr lang="en-US" altLang="zh-CN" sz="1400"/>
+          </a:p>
+          <a:p>
+            <a:pPr marL="571500" indent="-342900">
+              <a:buAutoNum type="arabicPeriod"/>
+            </a:pPr>
+            <a:r>
+              <a:rPr lang="zh-CN" altLang="en-US" sz="1400"/>
+              <a:t>将</a:t>
+            </a:r>
+            <a:r>
+              <a:rPr lang="zh-CN" altLang="en-US" sz="1400">
+                <a:solidFill>
+                  <a:schemeClr val="accent2"/>
+                </a:solidFill>
+              </a:rPr>
+              <a:t>输入信号接到每个</a:t>
+            </a:r>
+            <a:r>
+              <a:rPr lang="en-US" altLang="zh-CN" sz="1400">
+                <a:solidFill>
+                  <a:schemeClr val="accent2"/>
+                </a:solidFill>
+              </a:rPr>
+              <a:t>And</a:t>
+            </a:r>
+            <a:r>
+              <a:rPr lang="zh-CN" altLang="en-US" sz="1400">
+                <a:solidFill>
+                  <a:schemeClr val="accent2"/>
+                </a:solidFill>
+              </a:rPr>
+              <a:t>的</a:t>
+            </a:r>
+            <a:r>
+              <a:rPr lang="en-US" altLang="zh-CN" sz="1400">
+                <a:solidFill>
+                  <a:schemeClr val="accent2"/>
+                </a:solidFill>
+              </a:rPr>
+              <a:t>a</a:t>
+            </a:r>
+            <a:r>
+              <a:rPr lang="zh-CN" altLang="en-US" sz="1400">
+                <a:solidFill>
+                  <a:schemeClr val="accent2"/>
+                </a:solidFill>
+              </a:rPr>
+              <a:t>输入上</a:t>
+            </a:r>
+            <a:r>
+              <a:rPr lang="zh-CN" altLang="en-US" sz="1400"/>
+              <a:t>，</a:t>
+            </a:r>
+            <a:r>
+              <a:rPr lang="en-US" altLang="zh-CN" sz="1400"/>
+              <a:t>b</a:t>
+            </a:r>
+            <a:r>
+              <a:rPr lang="zh-CN" altLang="en-US" sz="1400"/>
+              <a:t>输入留给</a:t>
+            </a:r>
+            <a:r>
+              <a:rPr lang="en-US" altLang="zh-CN" sz="1400"/>
+              <a:t>sel</a:t>
+            </a:r>
+          </a:p>
+          <a:p>
+            <a:pPr marL="571500" indent="-342900">
+              <a:buAutoNum type="arabicPeriod"/>
+            </a:pPr>
+            <a:r>
+              <a:rPr lang="en-US" altLang="zh-CN" sz="1400"/>
+              <a:t>2way</a:t>
+            </a:r>
+            <a:r>
+              <a:rPr lang="zh-CN" altLang="en-US" sz="1400"/>
+              <a:t>、</a:t>
+            </a:r>
+            <a:r>
+              <a:rPr lang="en-US" altLang="zh-CN" sz="1400"/>
+              <a:t>4way</a:t>
+            </a:r>
+            <a:r>
+              <a:rPr lang="zh-CN" altLang="en-US" sz="1400"/>
+              <a:t>、</a:t>
+            </a:r>
+            <a:r>
+              <a:rPr lang="en-US" altLang="zh-CN" sz="1400"/>
+              <a:t>8way</a:t>
+            </a:r>
+            <a:r>
+              <a:rPr lang="zh-CN" altLang="en-US" sz="1400"/>
+              <a:t>、</a:t>
+            </a:r>
+            <a:r>
+              <a:rPr lang="en-US" altLang="zh-CN" sz="1400"/>
+              <a:t>16way</a:t>
+            </a:r>
+            <a:r>
+              <a:rPr lang="zh-CN" altLang="en-US" sz="1400"/>
+              <a:t>分别要</a:t>
+            </a:r>
+            <a:r>
+              <a:rPr lang="en-US" altLang="zh-CN" sz="1400"/>
+              <a:t>1</a:t>
+            </a:r>
+            <a:r>
+              <a:rPr lang="zh-CN" altLang="en-US" sz="1400"/>
+              <a:t>、</a:t>
+            </a:r>
+            <a:r>
+              <a:rPr lang="en-US" altLang="zh-CN" sz="1400"/>
+              <a:t>2</a:t>
+            </a:r>
+            <a:r>
+              <a:rPr lang="zh-CN" altLang="en-US" sz="1400"/>
+              <a:t>、</a:t>
+            </a:r>
+            <a:r>
+              <a:rPr lang="en-US" altLang="zh-CN" sz="1400"/>
+              <a:t>3</a:t>
+            </a:r>
+            <a:r>
+              <a:rPr lang="zh-CN" altLang="en-US" sz="1400"/>
+              <a:t>、</a:t>
+            </a:r>
+            <a:r>
+              <a:rPr lang="en-US" altLang="zh-CN" sz="1400"/>
+              <a:t>4</a:t>
+            </a:r>
+            <a:r>
+              <a:rPr lang="zh-CN" altLang="en-US" sz="1400"/>
+              <a:t>根</a:t>
+            </a:r>
+            <a:r>
+              <a:rPr lang="en-US" altLang="zh-CN" sz="1400"/>
+              <a:t>sel</a:t>
+            </a:r>
+          </a:p>
+          <a:p>
+            <a:pPr marL="571500" indent="-342900">
+              <a:buAutoNum type="arabicPeriod"/>
+            </a:pPr>
+            <a:r>
+              <a:rPr lang="zh-CN" altLang="en-US" sz="1400"/>
+              <a:t>以</a:t>
+            </a:r>
+            <a:r>
+              <a:rPr lang="en-US" altLang="zh-CN" sz="1400"/>
+              <a:t>4way</a:t>
+            </a:r>
+            <a:r>
+              <a:rPr lang="zh-CN" altLang="en-US" sz="1400"/>
+              <a:t>为例，列出真值表：</a:t>
+            </a:r>
+            <a:endParaRPr lang="en-US" altLang="zh-CN" sz="1400"/>
+          </a:p>
+          <a:p>
+            <a:pPr marL="571500" indent="-342900">
+              <a:buAutoNum type="arabicPeriod"/>
+            </a:pPr>
+            <a:endParaRPr lang="en-US" altLang="zh-CN" sz="1400"/>
+          </a:p>
+          <a:p>
+            <a:pPr marL="571500" indent="-342900">
+              <a:buAutoNum type="arabicPeriod"/>
+            </a:pPr>
+            <a:endParaRPr lang="en-US" altLang="zh-CN" sz="1400"/>
+          </a:p>
+          <a:p>
+            <a:pPr marL="571500" indent="-342900">
+              <a:buAutoNum type="arabicPeriod"/>
+            </a:pPr>
+            <a:endParaRPr lang="en-US" altLang="zh-CN" sz="1400"/>
+          </a:p>
+          <a:p>
+            <a:pPr marL="571500" indent="-342900">
+              <a:buAutoNum type="arabicPeriod"/>
+            </a:pPr>
+            <a:endParaRPr lang="en-US" altLang="zh-CN" sz="1400"/>
+          </a:p>
+          <a:p>
+            <a:pPr marL="571500" indent="-342900">
+              <a:buAutoNum type="arabicPeriod"/>
+            </a:pPr>
+            <a:endParaRPr lang="en-US" altLang="zh-CN" sz="1400"/>
+          </a:p>
+          <a:p>
+            <a:pPr marL="228600" indent="0"/>
+            <a:endParaRPr lang="en-US" altLang="zh-CN" sz="1400">
+              <a:solidFill>
+                <a:schemeClr val="accent2"/>
+              </a:solidFill>
+            </a:endParaRPr>
+          </a:p>
+          <a:p>
+            <a:pPr marL="228600" indent="0"/>
+            <a:r>
+              <a:rPr lang="en-US" altLang="zh-CN" sz="1400">
+                <a:solidFill>
+                  <a:schemeClr val="accent2"/>
+                </a:solidFill>
+              </a:rPr>
+              <a:t>DMUX</a:t>
+            </a:r>
+            <a:r>
+              <a:rPr lang="zh-CN" altLang="en-US" sz="1400">
+                <a:solidFill>
+                  <a:schemeClr val="accent2"/>
+                </a:solidFill>
+              </a:rPr>
+              <a:t>和</a:t>
+            </a:r>
+            <a:r>
+              <a:rPr lang="en-US" altLang="zh-CN" sz="1400">
+                <a:solidFill>
+                  <a:schemeClr val="accent2"/>
+                </a:solidFill>
+              </a:rPr>
+              <a:t>MUX</a:t>
+            </a:r>
+            <a:r>
+              <a:rPr lang="zh-CN" altLang="en-US" sz="1400">
+                <a:solidFill>
+                  <a:schemeClr val="accent2"/>
+                </a:solidFill>
+              </a:rPr>
+              <a:t>电路都是通过</a:t>
+            </a:r>
+            <a:r>
+              <a:rPr lang="en-US" altLang="zh-CN" sz="1400">
+                <a:solidFill>
+                  <a:schemeClr val="accent2"/>
+                </a:solidFill>
+              </a:rPr>
+              <a:t>S1S0</a:t>
+            </a:r>
+            <a:r>
+              <a:rPr lang="zh-CN" altLang="en-US" sz="1400">
+                <a:solidFill>
+                  <a:schemeClr val="accent2"/>
+                </a:solidFill>
+              </a:rPr>
+              <a:t>组合成</a:t>
+            </a:r>
+            <a:r>
+              <a:rPr lang="en-US" altLang="zh-CN" sz="1400">
+                <a:solidFill>
+                  <a:schemeClr val="accent2"/>
+                </a:solidFill>
+              </a:rPr>
+              <a:t>b</a:t>
+            </a:r>
+            <a:r>
+              <a:rPr lang="zh-CN" altLang="en-US" sz="1400">
+                <a:solidFill>
+                  <a:schemeClr val="accent2"/>
+                </a:solidFill>
+              </a:rPr>
+              <a:t>信号选路，</a:t>
+            </a:r>
+            <a:r>
+              <a:rPr lang="en-US" altLang="zh-CN" sz="1400">
+                <a:solidFill>
+                  <a:schemeClr val="accent2"/>
+                </a:solidFill>
+              </a:rPr>
+              <a:t>MUX</a:t>
+            </a:r>
+            <a:r>
+              <a:rPr lang="zh-CN" altLang="en-US" sz="1400">
+                <a:solidFill>
+                  <a:schemeClr val="accent2"/>
+                </a:solidFill>
+              </a:rPr>
+              <a:t>选的是输入、</a:t>
+            </a:r>
+            <a:r>
+              <a:rPr lang="en-US" altLang="zh-CN" sz="1400">
+                <a:solidFill>
+                  <a:schemeClr val="accent2"/>
+                </a:solidFill>
+              </a:rPr>
+              <a:t>DMUX</a:t>
+            </a:r>
+            <a:r>
+              <a:rPr lang="zh-CN" altLang="en-US" sz="1400">
+                <a:solidFill>
+                  <a:schemeClr val="accent2"/>
+                </a:solidFill>
+              </a:rPr>
+              <a:t>选的是输出</a:t>
+            </a:r>
+            <a:endParaRPr lang="en-US" altLang="zh-CN" sz="1400">
+              <a:solidFill>
+                <a:schemeClr val="accent2"/>
+              </a:solidFill>
+            </a:endParaRPr>
+          </a:p>
+          <a:p>
+            <a:pPr marL="228600" indent="0"/>
+            <a:endParaRPr lang="zh-CN" altLang="en-US" sz="1600"/>
+          </a:p>
+        </p:txBody>
+      </p:sp>
+      <p:sp>
+        <p:nvSpPr>
+          <p:cNvPr id="3" name="文本占位符 2">
+            <a:extLst>
+              <a:ext uri="{FF2B5EF4-FFF2-40B4-BE49-F238E27FC236}">
+                <a16:creationId xmlns:a16="http://schemas.microsoft.com/office/drawing/2014/main" id="{19413857-8EBC-7E21-4594-CCA95DDFEE5B}"/>
+              </a:ext>
+            </a:extLst>
+          </p:cNvPr>
+          <p:cNvSpPr>
+            <a:spLocks noGrp="1"/>
+          </p:cNvSpPr>
+          <p:nvPr>
+            <p:ph type="body" idx="2"/>
+          </p:nvPr>
+        </p:nvSpPr>
+        <p:spPr>
+          <a:xfrm>
+            <a:off x="339725" y="377428"/>
+            <a:ext cx="6421157" cy="621000"/>
+          </a:xfrm>
+        </p:spPr>
+        <p:txBody>
+          <a:bodyPr/>
+          <a:lstStyle/>
+          <a:p>
+            <a:r>
+              <a:rPr lang="en-US" altLang="zh-CN"/>
+              <a:t>2/4/8/16-Way 1-bit DMUX</a:t>
+            </a:r>
+            <a:r>
+              <a:rPr lang="zh-CN" altLang="en-US"/>
+              <a:t>通用电路图</a:t>
+            </a:r>
+            <a:endParaRPr lang="en-US" altLang="zh-CN"/>
+          </a:p>
+          <a:p>
+            <a:endParaRPr lang="zh-CN" altLang="en-US"/>
+          </a:p>
+        </p:txBody>
+      </p:sp>
+      <p:sp>
+        <p:nvSpPr>
+          <p:cNvPr id="4" name="灯片编号占位符 3">
+            <a:extLst>
+              <a:ext uri="{FF2B5EF4-FFF2-40B4-BE49-F238E27FC236}">
+                <a16:creationId xmlns:a16="http://schemas.microsoft.com/office/drawing/2014/main" id="{3F529E27-F811-6134-DF6F-9C0B0AA6485A}"/>
+              </a:ext>
+            </a:extLst>
+          </p:cNvPr>
+          <p:cNvSpPr>
+            <a:spLocks noGrp="1"/>
+          </p:cNvSpPr>
+          <p:nvPr>
+            <p:ph type="sldNum" idx="12"/>
+          </p:nvPr>
+        </p:nvSpPr>
+        <p:spPr/>
+        <p:txBody>
+          <a:bodyPr/>
+          <a:lstStyle/>
+          <a:p>
+            <a:pPr marL="0" marR="0" lvl="0" indent="0" algn="r" defTabSz="914400" rtl="0" eaLnBrk="1" fontAlgn="auto" latinLnBrk="0" hangingPunct="1">
+              <a:lnSpc>
+                <a:spcPct val="100000"/>
+              </a:lnSpc>
+              <a:spcBef>
+                <a:spcPts val="0"/>
+              </a:spcBef>
+              <a:spcAft>
+                <a:spcPts val="0"/>
+              </a:spcAft>
+              <a:buClr>
+                <a:srgbClr val="000000"/>
+              </a:buClr>
+              <a:buSzTx/>
+              <a:buFont typeface="Arial"/>
+              <a:buNone/>
+              <a:tabLst/>
+              <a:defRPr/>
+            </a:pPr>
+            <a:fld id="{00000000-1234-1234-1234-123412341234}" type="slidenum">
+              <a:rPr kumimoji="0" lang="en-GB" sz="1300" b="0" i="0" u="none" strike="noStrike" kern="0" cap="none" spc="0" normalizeH="0" baseline="0" noProof="0" smtClean="0">
+                <a:ln>
+                  <a:noFill/>
+                </a:ln>
+                <a:solidFill>
+                  <a:srgbClr val="000000"/>
+                </a:solidFill>
+                <a:effectLst/>
+                <a:uLnTx/>
+                <a:uFillTx/>
+                <a:latin typeface="Calibri"/>
+                <a:cs typeface="Calibri"/>
+                <a:sym typeface="Calibri"/>
+              </a:rPr>
+              <a:pPr marL="0" marR="0" lvl="0" indent="0" algn="r" defTabSz="914400" rtl="0" eaLnBrk="1" fontAlgn="auto" latinLnBrk="0" hangingPunct="1">
+                <a:lnSpc>
+                  <a:spcPct val="100000"/>
+                </a:lnSpc>
+                <a:spcBef>
+                  <a:spcPts val="0"/>
+                </a:spcBef>
+                <a:spcAft>
+                  <a:spcPts val="0"/>
+                </a:spcAft>
+                <a:buClr>
+                  <a:srgbClr val="000000"/>
+                </a:buClr>
+                <a:buSzTx/>
+                <a:buFont typeface="Arial"/>
+                <a:buNone/>
+                <a:tabLst/>
+                <a:defRPr/>
+              </a:pPr>
+              <a:t>26</a:t>
+            </a:fld>
+            <a:endParaRPr kumimoji="0" lang="en-GB" sz="1300" b="0" i="0" u="none" strike="noStrike" kern="0" cap="none" spc="0" normalizeH="0" baseline="0" noProof="0">
+              <a:ln>
+                <a:noFill/>
+              </a:ln>
+              <a:solidFill>
+                <a:srgbClr val="000000"/>
+              </a:solidFill>
+              <a:effectLst/>
+              <a:uLnTx/>
+              <a:uFillTx/>
+              <a:latin typeface="Calibri"/>
+              <a:cs typeface="Calibri"/>
+              <a:sym typeface="Calibri"/>
+            </a:endParaRPr>
+          </a:p>
+        </p:txBody>
+      </p:sp>
+      <p:graphicFrame>
+        <p:nvGraphicFramePr>
+          <p:cNvPr id="5" name="表格 4">
+            <a:extLst>
+              <a:ext uri="{FF2B5EF4-FFF2-40B4-BE49-F238E27FC236}">
+                <a16:creationId xmlns:a16="http://schemas.microsoft.com/office/drawing/2014/main" id="{A89AA39A-8462-974E-EFA2-8E916254D723}"/>
+              </a:ext>
+            </a:extLst>
+          </p:cNvPr>
+          <p:cNvGraphicFramePr>
+            <a:graphicFrameLocks noGrp="1"/>
+          </p:cNvGraphicFramePr>
+          <p:nvPr/>
+        </p:nvGraphicFramePr>
+        <p:xfrm>
+          <a:off x="473814" y="2557042"/>
+          <a:ext cx="4908550" cy="1369730"/>
+        </p:xfrm>
+        <a:graphic>
+          <a:graphicData uri="http://schemas.openxmlformats.org/drawingml/2006/table">
+            <a:tbl>
+              <a:tblPr firstRow="1" bandRow="1">
+                <a:tableStyleId>{5C22544A-7EE6-4342-B048-85BDC9FD1C3A}</a:tableStyleId>
+              </a:tblPr>
+              <a:tblGrid>
+                <a:gridCol w="564249">
+                  <a:extLst>
+                    <a:ext uri="{9D8B030D-6E8A-4147-A177-3AD203B41FA5}">
+                      <a16:colId xmlns:a16="http://schemas.microsoft.com/office/drawing/2014/main" val="2880815991"/>
+                    </a:ext>
+                  </a:extLst>
+                </a:gridCol>
+                <a:gridCol w="588015">
+                  <a:extLst>
+                    <a:ext uri="{9D8B030D-6E8A-4147-A177-3AD203B41FA5}">
+                      <a16:colId xmlns:a16="http://schemas.microsoft.com/office/drawing/2014/main" val="2359583450"/>
+                    </a:ext>
+                  </a:extLst>
+                </a:gridCol>
+                <a:gridCol w="1794465">
+                  <a:extLst>
+                    <a:ext uri="{9D8B030D-6E8A-4147-A177-3AD203B41FA5}">
+                      <a16:colId xmlns:a16="http://schemas.microsoft.com/office/drawing/2014/main" val="1723290835"/>
+                    </a:ext>
+                  </a:extLst>
+                </a:gridCol>
+                <a:gridCol w="1961821">
+                  <a:extLst>
+                    <a:ext uri="{9D8B030D-6E8A-4147-A177-3AD203B41FA5}">
+                      <a16:colId xmlns:a16="http://schemas.microsoft.com/office/drawing/2014/main" val="3499442225"/>
+                    </a:ext>
+                  </a:extLst>
+                </a:gridCol>
+              </a:tblGrid>
+              <a:tr h="273946">
+                <a:tc>
+                  <a:txBody>
+                    <a:bodyPr/>
+                    <a:lstStyle/>
+                    <a:p>
+                      <a:pPr algn="ctr"/>
+                      <a:r>
+                        <a:rPr lang="en-US" altLang="zh-CN" sz="1100"/>
+                        <a:t>S1</a:t>
+                      </a:r>
+                      <a:endParaRPr lang="zh-CN" altLang="en-US" sz="1100"/>
+                    </a:p>
+                  </a:txBody>
+                  <a:tcPr/>
+                </a:tc>
+                <a:tc>
+                  <a:txBody>
+                    <a:bodyPr/>
+                    <a:lstStyle/>
+                    <a:p>
+                      <a:pPr algn="ctr"/>
+                      <a:r>
+                        <a:rPr lang="en-US" altLang="zh-CN" sz="1100"/>
+                        <a:t>S0</a:t>
+                      </a:r>
+                      <a:endParaRPr lang="zh-CN" altLang="en-US" sz="1100"/>
+                    </a:p>
+                  </a:txBody>
+                  <a:tcPr/>
+                </a:tc>
+                <a:tc>
+                  <a:txBody>
+                    <a:bodyPr/>
+                    <a:lstStyle/>
+                    <a:p>
+                      <a:pPr algn="ctr"/>
+                      <a:r>
+                        <a:rPr lang="en-US" altLang="zh-CN" sz="1100"/>
+                        <a:t>S1S0</a:t>
+                      </a:r>
+                      <a:r>
+                        <a:rPr lang="zh-CN" altLang="en-US" sz="1100"/>
+                        <a:t>用</a:t>
+                      </a:r>
+                      <a:r>
+                        <a:rPr lang="en-US" altLang="zh-CN" sz="1100"/>
+                        <a:t>And</a:t>
+                      </a:r>
+                      <a:r>
+                        <a:rPr lang="zh-CN" altLang="en-US" sz="1100"/>
+                        <a:t>组合成</a:t>
+                      </a:r>
+                      <a:r>
+                        <a:rPr lang="en-US" altLang="zh-CN" sz="1100"/>
+                        <a:t>b</a:t>
+                      </a:r>
+                      <a:r>
+                        <a:rPr lang="zh-CN" altLang="en-US" sz="1100"/>
+                        <a:t>信号</a:t>
+                      </a:r>
+                    </a:p>
+                  </a:txBody>
+                  <a:tcPr/>
+                </a:tc>
+                <a:tc>
+                  <a:txBody>
+                    <a:bodyPr/>
+                    <a:lstStyle/>
+                    <a:p>
+                      <a:pPr algn="ctr"/>
+                      <a:r>
+                        <a:rPr lang="zh-CN" altLang="en-US" sz="1100"/>
+                        <a:t>接哪个</a:t>
+                      </a:r>
+                      <a:r>
+                        <a:rPr lang="en-US" altLang="zh-CN" sz="1100"/>
+                        <a:t>And</a:t>
+                      </a:r>
+                      <a:r>
+                        <a:rPr lang="zh-CN" altLang="en-US" sz="1100"/>
+                        <a:t>门的</a:t>
+                      </a:r>
+                      <a:r>
+                        <a:rPr lang="en-US" altLang="zh-CN" sz="1100"/>
+                        <a:t>b</a:t>
+                      </a:r>
+                      <a:r>
+                        <a:rPr lang="zh-CN" altLang="en-US" sz="1100"/>
+                        <a:t>信号</a:t>
+                      </a:r>
+                    </a:p>
+                  </a:txBody>
+                  <a:tcPr/>
+                </a:tc>
+                <a:extLst>
+                  <a:ext uri="{0D108BD9-81ED-4DB2-BD59-A6C34878D82A}">
+                    <a16:rowId xmlns:a16="http://schemas.microsoft.com/office/drawing/2014/main" val="4232458990"/>
+                  </a:ext>
+                </a:extLst>
+              </a:tr>
+              <a:tr h="273946">
+                <a:tc>
+                  <a:txBody>
+                    <a:bodyPr/>
+                    <a:lstStyle/>
+                    <a:p>
+                      <a:pPr algn="ctr"/>
+                      <a:r>
+                        <a:rPr lang="en-US" altLang="zh-CN" sz="1100"/>
+                        <a:t>0</a:t>
+                      </a:r>
+                      <a:endParaRPr lang="zh-CN" altLang="en-US" sz="1100"/>
+                    </a:p>
+                  </a:txBody>
+                  <a:tcPr/>
+                </a:tc>
+                <a:tc>
+                  <a:txBody>
+                    <a:bodyPr/>
+                    <a:lstStyle/>
+                    <a:p>
+                      <a:pPr algn="ctr"/>
+                      <a:r>
+                        <a:rPr lang="en-US" altLang="zh-CN" sz="1100"/>
+                        <a:t>0</a:t>
+                      </a:r>
+                      <a:endParaRPr lang="zh-CN" altLang="en-US" sz="1100"/>
+                    </a:p>
+                  </a:txBody>
+                  <a:tcPr/>
+                </a:tc>
+                <a:tc>
+                  <a:txBody>
+                    <a:bodyPr/>
+                    <a:lstStyle/>
+                    <a:p>
+                      <a:pPr algn="ctr"/>
+                      <a:r>
+                        <a:rPr lang="en-US" altLang="zh-CN" sz="1100"/>
+                        <a:t>S1S0</a:t>
+                      </a:r>
+                      <a:endParaRPr lang="zh-CN" altLang="en-US" sz="1100"/>
+                    </a:p>
+                  </a:txBody>
+                  <a:tcPr/>
+                </a:tc>
+                <a:tc>
+                  <a:txBody>
+                    <a:bodyPr/>
+                    <a:lstStyle/>
+                    <a:p>
+                      <a:pPr algn="ctr"/>
+                      <a:r>
+                        <a:rPr lang="en-US" altLang="zh-CN" sz="1100"/>
+                        <a:t>A</a:t>
+                      </a:r>
+                      <a:endParaRPr lang="zh-CN" altLang="en-US" sz="1100"/>
+                    </a:p>
+                  </a:txBody>
+                  <a:tcPr/>
+                </a:tc>
+                <a:extLst>
+                  <a:ext uri="{0D108BD9-81ED-4DB2-BD59-A6C34878D82A}">
+                    <a16:rowId xmlns:a16="http://schemas.microsoft.com/office/drawing/2014/main" val="3401603527"/>
+                  </a:ext>
+                </a:extLst>
+              </a:tr>
+              <a:tr h="273946">
+                <a:tc>
+                  <a:txBody>
+                    <a:bodyPr/>
+                    <a:lstStyle/>
+                    <a:p>
+                      <a:pPr algn="ctr"/>
+                      <a:r>
+                        <a:rPr lang="en-US" altLang="zh-CN" sz="1100"/>
+                        <a:t>0</a:t>
+                      </a:r>
+                      <a:endParaRPr lang="zh-CN" altLang="en-US" sz="1100"/>
+                    </a:p>
+                  </a:txBody>
+                  <a:tcPr/>
+                </a:tc>
+                <a:tc>
+                  <a:txBody>
+                    <a:bodyPr/>
+                    <a:lstStyle/>
+                    <a:p>
+                      <a:pPr algn="ctr"/>
+                      <a:r>
+                        <a:rPr lang="en-US" altLang="zh-CN" sz="1100"/>
+                        <a:t>1</a:t>
+                      </a:r>
+                      <a:endParaRPr lang="zh-CN" altLang="en-US" sz="1100"/>
+                    </a:p>
+                  </a:txBody>
+                  <a:tcPr/>
+                </a:tc>
+                <a:tc>
+                  <a:txBody>
+                    <a:bodyPr/>
+                    <a:lstStyle/>
+                    <a:p>
+                      <a:pPr marL="0" marR="0" lvl="0" indent="0" algn="ctr" defTabSz="914400" rtl="0" eaLnBrk="1" fontAlgn="auto" latinLnBrk="0" hangingPunct="1">
+                        <a:lnSpc>
+                          <a:spcPct val="100000"/>
+                        </a:lnSpc>
+                        <a:spcBef>
+                          <a:spcPts val="0"/>
+                        </a:spcBef>
+                        <a:spcAft>
+                          <a:spcPts val="0"/>
+                        </a:spcAft>
+                        <a:buClr>
+                          <a:srgbClr val="000000"/>
+                        </a:buClr>
+                        <a:buSzTx/>
+                        <a:buFont typeface="Arial"/>
+                        <a:buNone/>
+                        <a:tabLst/>
+                        <a:defRPr/>
+                      </a:pPr>
+                      <a:r>
+                        <a:rPr lang="en-US" altLang="zh-CN" sz="1100"/>
+                        <a:t>S1S0</a:t>
+                      </a:r>
+                      <a:endParaRPr lang="zh-CN" altLang="en-US" sz="1100"/>
+                    </a:p>
+                  </a:txBody>
+                  <a:tcPr/>
+                </a:tc>
+                <a:tc>
+                  <a:txBody>
+                    <a:bodyPr/>
+                    <a:lstStyle/>
+                    <a:p>
+                      <a:pPr algn="ctr"/>
+                      <a:r>
+                        <a:rPr lang="en-US" altLang="zh-CN" sz="1100"/>
+                        <a:t>B</a:t>
+                      </a:r>
+                      <a:endParaRPr lang="zh-CN" altLang="en-US" sz="1100"/>
+                    </a:p>
+                  </a:txBody>
+                  <a:tcPr/>
+                </a:tc>
+                <a:extLst>
+                  <a:ext uri="{0D108BD9-81ED-4DB2-BD59-A6C34878D82A}">
+                    <a16:rowId xmlns:a16="http://schemas.microsoft.com/office/drawing/2014/main" val="2420810354"/>
+                  </a:ext>
+                </a:extLst>
+              </a:tr>
+              <a:tr h="273946">
+                <a:tc>
+                  <a:txBody>
+                    <a:bodyPr/>
+                    <a:lstStyle/>
+                    <a:p>
+                      <a:pPr algn="ctr"/>
+                      <a:r>
+                        <a:rPr lang="en-US" altLang="zh-CN" sz="1100"/>
+                        <a:t>1</a:t>
+                      </a:r>
+                      <a:endParaRPr lang="zh-CN" altLang="en-US" sz="1100"/>
+                    </a:p>
+                  </a:txBody>
+                  <a:tcPr/>
+                </a:tc>
+                <a:tc>
+                  <a:txBody>
+                    <a:bodyPr/>
+                    <a:lstStyle/>
+                    <a:p>
+                      <a:pPr algn="ctr"/>
+                      <a:r>
+                        <a:rPr lang="en-US" altLang="zh-CN" sz="1100"/>
+                        <a:t>0</a:t>
+                      </a:r>
+                      <a:endParaRPr lang="zh-CN" altLang="en-US" sz="1100"/>
+                    </a:p>
+                  </a:txBody>
+                  <a:tcPr/>
+                </a:tc>
+                <a:tc>
+                  <a:txBody>
+                    <a:bodyPr/>
+                    <a:lstStyle/>
+                    <a:p>
+                      <a:pPr marL="0" marR="0" lvl="0" indent="0" algn="ctr" defTabSz="914400" rtl="0" eaLnBrk="1" fontAlgn="auto" latinLnBrk="0" hangingPunct="1">
+                        <a:lnSpc>
+                          <a:spcPct val="100000"/>
+                        </a:lnSpc>
+                        <a:spcBef>
+                          <a:spcPts val="0"/>
+                        </a:spcBef>
+                        <a:spcAft>
+                          <a:spcPts val="0"/>
+                        </a:spcAft>
+                        <a:buClr>
+                          <a:srgbClr val="000000"/>
+                        </a:buClr>
+                        <a:buSzTx/>
+                        <a:buFont typeface="Arial"/>
+                        <a:buNone/>
+                        <a:tabLst/>
+                        <a:defRPr/>
+                      </a:pPr>
+                      <a:r>
+                        <a:rPr lang="en-US" altLang="zh-CN" sz="1100"/>
+                        <a:t>S1S0</a:t>
+                      </a:r>
+                      <a:endParaRPr lang="zh-CN" altLang="en-US" sz="1100"/>
+                    </a:p>
+                  </a:txBody>
+                  <a:tcPr/>
+                </a:tc>
+                <a:tc>
+                  <a:txBody>
+                    <a:bodyPr/>
+                    <a:lstStyle/>
+                    <a:p>
+                      <a:pPr algn="ctr"/>
+                      <a:r>
+                        <a:rPr lang="en-US" altLang="zh-CN" sz="1100"/>
+                        <a:t>C</a:t>
+                      </a:r>
+                      <a:endParaRPr lang="zh-CN" altLang="en-US" sz="1100"/>
+                    </a:p>
+                  </a:txBody>
+                  <a:tcPr/>
+                </a:tc>
+                <a:extLst>
+                  <a:ext uri="{0D108BD9-81ED-4DB2-BD59-A6C34878D82A}">
+                    <a16:rowId xmlns:a16="http://schemas.microsoft.com/office/drawing/2014/main" val="2711586362"/>
+                  </a:ext>
+                </a:extLst>
+              </a:tr>
+              <a:tr h="273946">
+                <a:tc>
+                  <a:txBody>
+                    <a:bodyPr/>
+                    <a:lstStyle/>
+                    <a:p>
+                      <a:pPr algn="ctr"/>
+                      <a:r>
+                        <a:rPr lang="en-US" altLang="zh-CN" sz="1100"/>
+                        <a:t>1</a:t>
+                      </a:r>
+                      <a:endParaRPr lang="zh-CN" altLang="en-US" sz="1100"/>
+                    </a:p>
+                  </a:txBody>
+                  <a:tcPr/>
+                </a:tc>
+                <a:tc>
+                  <a:txBody>
+                    <a:bodyPr/>
+                    <a:lstStyle/>
+                    <a:p>
+                      <a:pPr algn="ctr"/>
+                      <a:r>
+                        <a:rPr lang="en-US" altLang="zh-CN" sz="1100"/>
+                        <a:t>1</a:t>
+                      </a:r>
+                      <a:endParaRPr lang="zh-CN" altLang="en-US" sz="1100"/>
+                    </a:p>
+                  </a:txBody>
+                  <a:tcPr/>
+                </a:tc>
+                <a:tc>
+                  <a:txBody>
+                    <a:bodyPr/>
+                    <a:lstStyle/>
+                    <a:p>
+                      <a:pPr marL="0" marR="0" lvl="0" indent="0" algn="ctr" defTabSz="914400" rtl="0" eaLnBrk="1" fontAlgn="auto" latinLnBrk="0" hangingPunct="1">
+                        <a:lnSpc>
+                          <a:spcPct val="100000"/>
+                        </a:lnSpc>
+                        <a:spcBef>
+                          <a:spcPts val="0"/>
+                        </a:spcBef>
+                        <a:spcAft>
+                          <a:spcPts val="0"/>
+                        </a:spcAft>
+                        <a:buClr>
+                          <a:srgbClr val="000000"/>
+                        </a:buClr>
+                        <a:buSzTx/>
+                        <a:buFont typeface="Arial"/>
+                        <a:buNone/>
+                        <a:tabLst/>
+                        <a:defRPr/>
+                      </a:pPr>
+                      <a:r>
+                        <a:rPr lang="en-US" altLang="zh-CN" sz="1100"/>
+                        <a:t>S1S0</a:t>
+                      </a:r>
+                      <a:endParaRPr lang="zh-CN" altLang="en-US" sz="1100"/>
+                    </a:p>
+                  </a:txBody>
+                  <a:tcPr/>
+                </a:tc>
+                <a:tc>
+                  <a:txBody>
+                    <a:bodyPr/>
+                    <a:lstStyle/>
+                    <a:p>
+                      <a:pPr algn="ctr"/>
+                      <a:r>
+                        <a:rPr lang="en-US" altLang="zh-CN" sz="1100"/>
+                        <a:t>D</a:t>
+                      </a:r>
+                      <a:endParaRPr lang="zh-CN" altLang="en-US" sz="1100"/>
+                    </a:p>
+                  </a:txBody>
+                  <a:tcPr/>
+                </a:tc>
+                <a:extLst>
+                  <a:ext uri="{0D108BD9-81ED-4DB2-BD59-A6C34878D82A}">
+                    <a16:rowId xmlns:a16="http://schemas.microsoft.com/office/drawing/2014/main" val="2533759617"/>
+                  </a:ext>
+                </a:extLst>
+              </a:tr>
+            </a:tbl>
+          </a:graphicData>
+        </a:graphic>
+      </p:graphicFrame>
+      <p:cxnSp>
+        <p:nvCxnSpPr>
+          <p:cNvPr id="7" name="直接连接符 6">
+            <a:extLst>
+              <a:ext uri="{FF2B5EF4-FFF2-40B4-BE49-F238E27FC236}">
+                <a16:creationId xmlns:a16="http://schemas.microsoft.com/office/drawing/2014/main" id="{3970B71E-F0AD-3B57-D715-BBB7FE7791C7}"/>
+              </a:ext>
+            </a:extLst>
+          </p:cNvPr>
+          <p:cNvCxnSpPr>
+            <a:cxnSpLocks/>
+          </p:cNvCxnSpPr>
+          <p:nvPr/>
+        </p:nvCxnSpPr>
+        <p:spPr>
+          <a:xfrm>
+            <a:off x="2356480" y="2873005"/>
+            <a:ext cx="155203" cy="0"/>
+          </a:xfrm>
+          <a:prstGeom prst="line">
+            <a:avLst/>
+          </a:prstGeom>
+        </p:spPr>
+        <p:style>
+          <a:lnRef idx="1">
+            <a:schemeClr val="dk1"/>
+          </a:lnRef>
+          <a:fillRef idx="0">
+            <a:schemeClr val="dk1"/>
+          </a:fillRef>
+          <a:effectRef idx="0">
+            <a:schemeClr val="dk1"/>
+          </a:effectRef>
+          <a:fontRef idx="minor">
+            <a:schemeClr val="tx1"/>
+          </a:fontRef>
+        </p:style>
+      </p:cxnSp>
+      <p:cxnSp>
+        <p:nvCxnSpPr>
+          <p:cNvPr id="9" name="直接连接符 8">
+            <a:extLst>
+              <a:ext uri="{FF2B5EF4-FFF2-40B4-BE49-F238E27FC236}">
+                <a16:creationId xmlns:a16="http://schemas.microsoft.com/office/drawing/2014/main" id="{34161E47-75CC-EABE-252F-C636FECAC0D6}"/>
+              </a:ext>
+            </a:extLst>
+          </p:cNvPr>
+          <p:cNvCxnSpPr>
+            <a:cxnSpLocks/>
+          </p:cNvCxnSpPr>
+          <p:nvPr/>
+        </p:nvCxnSpPr>
+        <p:spPr>
+          <a:xfrm>
+            <a:off x="2532698" y="2873005"/>
+            <a:ext cx="155203" cy="0"/>
+          </a:xfrm>
+          <a:prstGeom prst="line">
+            <a:avLst/>
+          </a:prstGeom>
+        </p:spPr>
+        <p:style>
+          <a:lnRef idx="1">
+            <a:schemeClr val="dk1"/>
+          </a:lnRef>
+          <a:fillRef idx="0">
+            <a:schemeClr val="dk1"/>
+          </a:fillRef>
+          <a:effectRef idx="0">
+            <a:schemeClr val="dk1"/>
+          </a:effectRef>
+          <a:fontRef idx="minor">
+            <a:schemeClr val="tx1"/>
+          </a:fontRef>
+        </p:style>
+      </p:cxnSp>
+      <p:cxnSp>
+        <p:nvCxnSpPr>
+          <p:cNvPr id="10" name="直接连接符 9">
+            <a:extLst>
+              <a:ext uri="{FF2B5EF4-FFF2-40B4-BE49-F238E27FC236}">
+                <a16:creationId xmlns:a16="http://schemas.microsoft.com/office/drawing/2014/main" id="{AB81595F-B181-AD8D-B341-4A8907398086}"/>
+              </a:ext>
+            </a:extLst>
+          </p:cNvPr>
+          <p:cNvCxnSpPr>
+            <a:cxnSpLocks/>
+          </p:cNvCxnSpPr>
+          <p:nvPr/>
+        </p:nvCxnSpPr>
+        <p:spPr>
+          <a:xfrm>
+            <a:off x="2352035" y="3142881"/>
+            <a:ext cx="155203" cy="0"/>
+          </a:xfrm>
+          <a:prstGeom prst="line">
+            <a:avLst/>
+          </a:prstGeom>
+        </p:spPr>
+        <p:style>
+          <a:lnRef idx="1">
+            <a:schemeClr val="dk1"/>
+          </a:lnRef>
+          <a:fillRef idx="0">
+            <a:schemeClr val="dk1"/>
+          </a:fillRef>
+          <a:effectRef idx="0">
+            <a:schemeClr val="dk1"/>
+          </a:effectRef>
+          <a:fontRef idx="minor">
+            <a:schemeClr val="tx1"/>
+          </a:fontRef>
+        </p:style>
+      </p:cxnSp>
+      <p:cxnSp>
+        <p:nvCxnSpPr>
+          <p:cNvPr id="11" name="直接连接符 10">
+            <a:extLst>
+              <a:ext uri="{FF2B5EF4-FFF2-40B4-BE49-F238E27FC236}">
+                <a16:creationId xmlns:a16="http://schemas.microsoft.com/office/drawing/2014/main" id="{8B6E9413-32A4-3AED-59E8-911D548F1366}"/>
+              </a:ext>
+            </a:extLst>
+          </p:cNvPr>
+          <p:cNvCxnSpPr>
+            <a:cxnSpLocks/>
+          </p:cNvCxnSpPr>
+          <p:nvPr/>
+        </p:nvCxnSpPr>
+        <p:spPr>
+          <a:xfrm>
+            <a:off x="2502530" y="3428313"/>
+            <a:ext cx="155203" cy="0"/>
+          </a:xfrm>
+          <a:prstGeom prst="line">
+            <a:avLst/>
+          </a:prstGeom>
+        </p:spPr>
+        <p:style>
+          <a:lnRef idx="1">
+            <a:schemeClr val="dk1"/>
+          </a:lnRef>
+          <a:fillRef idx="0">
+            <a:schemeClr val="dk1"/>
+          </a:fillRef>
+          <a:effectRef idx="0">
+            <a:schemeClr val="dk1"/>
+          </a:effectRef>
+          <a:fontRef idx="minor">
+            <a:schemeClr val="tx1"/>
+          </a:fontRef>
+        </p:style>
+      </p:cxnSp>
+      <p:pic>
+        <p:nvPicPr>
+          <p:cNvPr id="8" name="图片 7">
+            <a:extLst>
+              <a:ext uri="{FF2B5EF4-FFF2-40B4-BE49-F238E27FC236}">
+                <a16:creationId xmlns:a16="http://schemas.microsoft.com/office/drawing/2014/main" id="{23A3461F-36F8-B87C-217E-744B44FDF63A}"/>
+              </a:ext>
+            </a:extLst>
+          </p:cNvPr>
+          <p:cNvPicPr>
+            <a:picLocks noChangeAspect="1"/>
+          </p:cNvPicPr>
+          <p:nvPr/>
+        </p:nvPicPr>
+        <p:blipFill>
+          <a:blip r:embed="rId3"/>
+          <a:stretch>
+            <a:fillRect/>
+          </a:stretch>
+        </p:blipFill>
+        <p:spPr>
+          <a:xfrm>
+            <a:off x="5516454" y="1045790"/>
+            <a:ext cx="3153732" cy="3313550"/>
+          </a:xfrm>
+          <a:prstGeom prst="rect">
+            <a:avLst/>
+          </a:prstGeom>
+        </p:spPr>
+      </p:pic>
+    </p:spTree>
+    <p:extLst>
+      <p:ext uri="{BB962C8B-B14F-4D97-AF65-F5344CB8AC3E}">
+        <p14:creationId xmlns:p14="http://schemas.microsoft.com/office/powerpoint/2010/main" val="2907976332"/>
+      </p:ext>
+    </p:extLst>
+  </p:cSld>
+  <p:clrMapOvr>
+    <a:masterClrMapping/>
+  </p:clrMapOvr>
+</p:sld>
+</file>
+
+<file path=ppt/slides/slide27.xml><?xml version="1.0" encoding="utf-8"?>
 <p:sld xmlns:a="http://schemas.openxmlformats.org/drawingml/2006/main" xmlns:r="http://schemas.openxmlformats.org/officeDocument/2006/relationships" xmlns:p="http://schemas.openxmlformats.org/presentationml/2006/main">
   <p:cSld>
     <p:spTree>
@@ -33463,7 +36070,7 @@
             </a:pPr>
             <a:fld id="{00000000-1234-1234-1234-123412341234}" type="slidenum">
               <a:rPr lang="en-GB" smtClean="0"/>
-              <a:t>25</a:t>
+              <a:t>27</a:t>
             </a:fld>
             <a:endParaRPr lang="en-GB"/>
           </a:p>
@@ -36239,7 +38846,7 @@
 </p:sld>
 </file>
 
-<file path=ppt/slides/slide26.xml><?xml version="1.0" encoding="utf-8"?>
+<file path=ppt/slides/slide28.xml><?xml version="1.0" encoding="utf-8"?>
 <p:sld xmlns:a="http://schemas.openxmlformats.org/drawingml/2006/main" xmlns:r="http://schemas.openxmlformats.org/officeDocument/2006/relationships" xmlns:p="http://schemas.openxmlformats.org/presentationml/2006/main">
   <p:cSld>
     <p:spTree>
@@ -36478,7 +39085,7 @@
             </a:pPr>
             <a:fld id="{00000000-1234-1234-1234-123412341234}" type="slidenum">
               <a:rPr lang="en-GB" smtClean="0"/>
-              <a:t>26</a:t>
+              <a:t>28</a:t>
             </a:fld>
             <a:endParaRPr lang="en-GB"/>
           </a:p>
@@ -37045,7 +39652,7 @@
 </p:sld>
 </file>
 
-<file path=ppt/slides/slide27.xml><?xml version="1.0" encoding="utf-8"?>
+<file path=ppt/slides/slide29.xml><?xml version="1.0" encoding="utf-8"?>
 <p:sld xmlns:a="http://schemas.openxmlformats.org/drawingml/2006/main" xmlns:r="http://schemas.openxmlformats.org/officeDocument/2006/relationships" xmlns:p="http://schemas.openxmlformats.org/presentationml/2006/main">
   <p:cSld>
     <p:spTree>
@@ -37227,7 +39834,7 @@
             </a:pPr>
             <a:fld id="{00000000-1234-1234-1234-123412341234}" type="slidenum">
               <a:rPr lang="en-GB" smtClean="0"/>
-              <a:t>27</a:t>
+              <a:t>29</a:t>
             </a:fld>
             <a:endParaRPr lang="en-GB"/>
           </a:p>
@@ -37276,7 +39883,196 @@
 </p:sld>
 </file>
 
-<file path=ppt/slides/slide28.xml><?xml version="1.0" encoding="utf-8"?>
+<file path=ppt/slides/slide3.xml><?xml version="1.0" encoding="utf-8"?>
+<p:sld xmlns:a="http://schemas.openxmlformats.org/drawingml/2006/main" xmlns:r="http://schemas.openxmlformats.org/officeDocument/2006/relationships" xmlns:p="http://schemas.openxmlformats.org/presentationml/2006/main">
+  <p:cSld>
+    <p:spTree>
+      <p:nvGrpSpPr>
+        <p:cNvPr id="1" name=""/>
+        <p:cNvGrpSpPr/>
+        <p:nvPr/>
+      </p:nvGrpSpPr>
+      <p:grpSpPr>
+        <a:xfrm>
+          <a:off x="0" y="0"/>
+          <a:ext cx="0" cy="0"/>
+          <a:chOff x="0" y="0"/>
+          <a:chExt cx="0" cy="0"/>
+        </a:xfrm>
+      </p:grpSpPr>
+      <p:sp>
+        <p:nvSpPr>
+          <p:cNvPr id="2" name="Title 1">
+            <a:extLst>
+              <a:ext uri="{FF2B5EF4-FFF2-40B4-BE49-F238E27FC236}">
+                <a16:creationId xmlns:a16="http://schemas.microsoft.com/office/drawing/2014/main" id="{FE22FD2E-7CB8-D672-DB56-86199687FD96}"/>
+              </a:ext>
+            </a:extLst>
+          </p:cNvPr>
+          <p:cNvSpPr>
+            <a:spLocks noGrp="1"/>
+          </p:cNvSpPr>
+          <p:nvPr>
+            <p:ph type="title"/>
+          </p:nvPr>
+        </p:nvSpPr>
+        <p:spPr/>
+        <p:txBody>
+          <a:bodyPr/>
+          <a:lstStyle/>
+          <a:p>
+            <a:endParaRPr lang="en-US"/>
+          </a:p>
+        </p:txBody>
+      </p:sp>
+      <p:sp>
+        <p:nvSpPr>
+          <p:cNvPr id="3" name="Slide Number Placeholder 2">
+            <a:extLst>
+              <a:ext uri="{FF2B5EF4-FFF2-40B4-BE49-F238E27FC236}">
+                <a16:creationId xmlns:a16="http://schemas.microsoft.com/office/drawing/2014/main" id="{BE4C0CC6-8565-8369-306D-D722B5931D56}"/>
+              </a:ext>
+            </a:extLst>
+          </p:cNvPr>
+          <p:cNvSpPr>
+            <a:spLocks noGrp="1"/>
+          </p:cNvSpPr>
+          <p:nvPr>
+            <p:ph type="sldNum" sz="quarter" idx="12"/>
+          </p:nvPr>
+        </p:nvSpPr>
+        <p:spPr/>
+        <p:txBody>
+          <a:bodyPr/>
+          <a:lstStyle/>
+          <a:p>
+            <a:fld id="{9D4AD3D6-B89C-4D82-B254-B84B3D342745}" type="slidenum">
+              <a:rPr lang="en-FI" smtClean="0"/>
+              <a:t>3</a:t>
+            </a:fld>
+            <a:endParaRPr lang="en-FI"/>
+          </a:p>
+        </p:txBody>
+      </p:sp>
+      <p:sp>
+        <p:nvSpPr>
+          <p:cNvPr id="5" name="TextBox 4">
+            <a:extLst>
+              <a:ext uri="{FF2B5EF4-FFF2-40B4-BE49-F238E27FC236}">
+                <a16:creationId xmlns:a16="http://schemas.microsoft.com/office/drawing/2014/main" id="{CB38000C-B6BB-B788-95CD-1F6EEAA225AC}"/>
+              </a:ext>
+            </a:extLst>
+          </p:cNvPr>
+          <p:cNvSpPr txBox="1"/>
+          <p:nvPr/>
+        </p:nvSpPr>
+        <p:spPr>
+          <a:xfrm>
+            <a:off x="251520" y="469075"/>
+            <a:ext cx="1802096" cy="523220"/>
+          </a:xfrm>
+          <a:prstGeom prst="rect">
+            <a:avLst/>
+          </a:prstGeom>
+          <a:noFill/>
+        </p:spPr>
+        <p:txBody>
+          <a:bodyPr wrap="none" rtlCol="0">
+            <a:spAutoFit/>
+          </a:bodyPr>
+          <a:lstStyle/>
+          <a:p>
+            <a:r>
+              <a:rPr lang="en-US" sz="2800"/>
+              <a:t>Text Book</a:t>
+            </a:r>
+          </a:p>
+        </p:txBody>
+      </p:sp>
+      <p:sp>
+        <p:nvSpPr>
+          <p:cNvPr id="7" name="TextBox 6">
+            <a:extLst>
+              <a:ext uri="{FF2B5EF4-FFF2-40B4-BE49-F238E27FC236}">
+                <a16:creationId xmlns:a16="http://schemas.microsoft.com/office/drawing/2014/main" id="{DD9D275F-02DB-D409-4754-D54FCC1E8396}"/>
+              </a:ext>
+            </a:extLst>
+          </p:cNvPr>
+          <p:cNvSpPr txBox="1"/>
+          <p:nvPr/>
+        </p:nvSpPr>
+        <p:spPr>
+          <a:xfrm>
+            <a:off x="386534" y="1348740"/>
+            <a:ext cx="6525725" cy="784830"/>
+          </a:xfrm>
+          <a:prstGeom prst="rect">
+            <a:avLst/>
+          </a:prstGeom>
+          <a:noFill/>
+        </p:spPr>
+        <p:txBody>
+          <a:bodyPr wrap="square">
+            <a:spAutoFit/>
+          </a:bodyPr>
+          <a:lstStyle/>
+          <a:p>
+            <a:pPr marL="0" lvl="1" indent="0">
+              <a:lnSpc>
+                <a:spcPct val="100000"/>
+              </a:lnSpc>
+              <a:spcBef>
+                <a:spcPts val="600"/>
+              </a:spcBef>
+              <a:buSzPct val="100000"/>
+              <a:buNone/>
+            </a:pPr>
+            <a:r>
+              <a:rPr lang="en-US" sz="2000"/>
+              <a:t>Nand2Tetris HDL Guide / Documentation:</a:t>
+            </a:r>
+          </a:p>
+          <a:p>
+            <a:pPr marL="0" lvl="1" indent="0">
+              <a:lnSpc>
+                <a:spcPct val="100000"/>
+              </a:lnSpc>
+              <a:spcBef>
+                <a:spcPts val="600"/>
+              </a:spcBef>
+              <a:buSzPct val="100000"/>
+              <a:buNone/>
+            </a:pPr>
+            <a:r>
+              <a:rPr lang="en-US" sz="2000" i="1">
+                <a:hlinkClick r:id="rId2"/>
+              </a:rPr>
+              <a:t>The Elements of Computing Systems</a:t>
+            </a:r>
+            <a:r>
+              <a:rPr lang="en-US" sz="2000">
+                <a:hlinkClick r:id="rId2"/>
+              </a:rPr>
+              <a:t> / Appendix 2: HDL</a:t>
+            </a:r>
+            <a:endParaRPr lang="en-US" sz="2000"/>
+          </a:p>
+        </p:txBody>
+      </p:sp>
+    </p:spTree>
+    <p:extLst>
+      <p:ext uri="{BB962C8B-B14F-4D97-AF65-F5344CB8AC3E}">
+        <p14:creationId xmlns:p14="http://schemas.microsoft.com/office/powerpoint/2010/main" val="3010950633"/>
+      </p:ext>
+    </p:extLst>
+  </p:cSld>
+  <p:clrMapOvr>
+    <a:masterClrMapping/>
+  </p:clrMapOvr>
+</p:sld>
+</file>
+
+<file path=ppt/slides/slide30.xml><?xml version="1.0" encoding="utf-8"?>
 <p:sld xmlns:a="http://schemas.openxmlformats.org/drawingml/2006/main" xmlns:r="http://schemas.openxmlformats.org/officeDocument/2006/relationships" xmlns:p="http://schemas.openxmlformats.org/presentationml/2006/main">
   <p:cSld>
     <p:spTree>
@@ -37359,7 +40155,7 @@
             </a:pPr>
             <a:fld id="{00000000-1234-1234-1234-123412341234}" type="slidenum">
               <a:rPr lang="en-GB" smtClean="0"/>
-              <a:t>28</a:t>
+              <a:t>30</a:t>
             </a:fld>
             <a:endParaRPr lang="en-GB"/>
           </a:p>
@@ -38873,7 +41669,7 @@
 </p:sld>
 </file>
 
-<file path=ppt/slides/slide29.xml><?xml version="1.0" encoding="utf-8"?>
+<file path=ppt/slides/slide31.xml><?xml version="1.0" encoding="utf-8"?>
 <p:sld xmlns:a="http://schemas.openxmlformats.org/drawingml/2006/main" xmlns:r="http://schemas.openxmlformats.org/officeDocument/2006/relationships" xmlns:p="http://schemas.openxmlformats.org/presentationml/2006/main">
   <p:cSld>
     <p:spTree>
@@ -38944,7 +41740,7 @@
           <a:p>
             <a:fld id="{9D4AD3D6-B89C-4D82-B254-B84B3D342745}" type="slidenum">
               <a:rPr lang="en-FI" smtClean="0"/>
-              <a:t>29</a:t>
+              <a:t>31</a:t>
             </a:fld>
             <a:endParaRPr lang="en-FI"/>
           </a:p>
@@ -39090,195 +41886,6 @@
     <p:extLst>
       <p:ext uri="{BB962C8B-B14F-4D97-AF65-F5344CB8AC3E}">
         <p14:creationId xmlns:p14="http://schemas.microsoft.com/office/powerpoint/2010/main" val="2178100593"/>
-      </p:ext>
-    </p:extLst>
-  </p:cSld>
-  <p:clrMapOvr>
-    <a:masterClrMapping/>
-  </p:clrMapOvr>
-</p:sld>
-</file>
-
-<file path=ppt/slides/slide3.xml><?xml version="1.0" encoding="utf-8"?>
-<p:sld xmlns:a="http://schemas.openxmlformats.org/drawingml/2006/main" xmlns:r="http://schemas.openxmlformats.org/officeDocument/2006/relationships" xmlns:p="http://schemas.openxmlformats.org/presentationml/2006/main">
-  <p:cSld>
-    <p:spTree>
-      <p:nvGrpSpPr>
-        <p:cNvPr id="1" name=""/>
-        <p:cNvGrpSpPr/>
-        <p:nvPr/>
-      </p:nvGrpSpPr>
-      <p:grpSpPr>
-        <a:xfrm>
-          <a:off x="0" y="0"/>
-          <a:ext cx="0" cy="0"/>
-          <a:chOff x="0" y="0"/>
-          <a:chExt cx="0" cy="0"/>
-        </a:xfrm>
-      </p:grpSpPr>
-      <p:sp>
-        <p:nvSpPr>
-          <p:cNvPr id="2" name="Title 1">
-            <a:extLst>
-              <a:ext uri="{FF2B5EF4-FFF2-40B4-BE49-F238E27FC236}">
-                <a16:creationId xmlns:a16="http://schemas.microsoft.com/office/drawing/2014/main" id="{FE22FD2E-7CB8-D672-DB56-86199687FD96}"/>
-              </a:ext>
-            </a:extLst>
-          </p:cNvPr>
-          <p:cNvSpPr>
-            <a:spLocks noGrp="1"/>
-          </p:cNvSpPr>
-          <p:nvPr>
-            <p:ph type="title"/>
-          </p:nvPr>
-        </p:nvSpPr>
-        <p:spPr/>
-        <p:txBody>
-          <a:bodyPr/>
-          <a:lstStyle/>
-          <a:p>
-            <a:endParaRPr lang="en-US"/>
-          </a:p>
-        </p:txBody>
-      </p:sp>
-      <p:sp>
-        <p:nvSpPr>
-          <p:cNvPr id="3" name="Slide Number Placeholder 2">
-            <a:extLst>
-              <a:ext uri="{FF2B5EF4-FFF2-40B4-BE49-F238E27FC236}">
-                <a16:creationId xmlns:a16="http://schemas.microsoft.com/office/drawing/2014/main" id="{BE4C0CC6-8565-8369-306D-D722B5931D56}"/>
-              </a:ext>
-            </a:extLst>
-          </p:cNvPr>
-          <p:cNvSpPr>
-            <a:spLocks noGrp="1"/>
-          </p:cNvSpPr>
-          <p:nvPr>
-            <p:ph type="sldNum" sz="quarter" idx="12"/>
-          </p:nvPr>
-        </p:nvSpPr>
-        <p:spPr/>
-        <p:txBody>
-          <a:bodyPr/>
-          <a:lstStyle/>
-          <a:p>
-            <a:fld id="{9D4AD3D6-B89C-4D82-B254-B84B3D342745}" type="slidenum">
-              <a:rPr lang="en-FI" smtClean="0"/>
-              <a:t>3</a:t>
-            </a:fld>
-            <a:endParaRPr lang="en-FI"/>
-          </a:p>
-        </p:txBody>
-      </p:sp>
-      <p:sp>
-        <p:nvSpPr>
-          <p:cNvPr id="5" name="TextBox 4">
-            <a:extLst>
-              <a:ext uri="{FF2B5EF4-FFF2-40B4-BE49-F238E27FC236}">
-                <a16:creationId xmlns:a16="http://schemas.microsoft.com/office/drawing/2014/main" id="{CB38000C-B6BB-B788-95CD-1F6EEAA225AC}"/>
-              </a:ext>
-            </a:extLst>
-          </p:cNvPr>
-          <p:cNvSpPr txBox="1"/>
-          <p:nvPr/>
-        </p:nvSpPr>
-        <p:spPr>
-          <a:xfrm>
-            <a:off x="251520" y="469075"/>
-            <a:ext cx="1802096" cy="523220"/>
-          </a:xfrm>
-          <a:prstGeom prst="rect">
-            <a:avLst/>
-          </a:prstGeom>
-          <a:noFill/>
-        </p:spPr>
-        <p:txBody>
-          <a:bodyPr wrap="none" rtlCol="0">
-            <a:spAutoFit/>
-          </a:bodyPr>
-          <a:lstStyle/>
-          <a:p>
-            <a:r>
-              <a:rPr lang="en-US" sz="2800"/>
-              <a:t>Text Book</a:t>
-            </a:r>
-          </a:p>
-        </p:txBody>
-      </p:sp>
-      <p:sp>
-        <p:nvSpPr>
-          <p:cNvPr id="7" name="TextBox 6">
-            <a:extLst>
-              <a:ext uri="{FF2B5EF4-FFF2-40B4-BE49-F238E27FC236}">
-                <a16:creationId xmlns:a16="http://schemas.microsoft.com/office/drawing/2014/main" id="{DD9D275F-02DB-D409-4754-D54FCC1E8396}"/>
-              </a:ext>
-            </a:extLst>
-          </p:cNvPr>
-          <p:cNvSpPr txBox="1"/>
-          <p:nvPr/>
-        </p:nvSpPr>
-        <p:spPr>
-          <a:xfrm>
-            <a:off x="386534" y="1348740"/>
-            <a:ext cx="6525725" cy="784830"/>
-          </a:xfrm>
-          <a:prstGeom prst="rect">
-            <a:avLst/>
-          </a:prstGeom>
-          <a:noFill/>
-        </p:spPr>
-        <p:txBody>
-          <a:bodyPr wrap="square">
-            <a:spAutoFit/>
-          </a:bodyPr>
-          <a:lstStyle/>
-          <a:p>
-            <a:pPr marL="0" lvl="1" indent="0">
-              <a:lnSpc>
-                <a:spcPct val="100000"/>
-              </a:lnSpc>
-              <a:spcBef>
-                <a:spcPts val="600"/>
-              </a:spcBef>
-              <a:buSzPct val="100000"/>
-              <a:buNone/>
-            </a:pPr>
-            <a:r>
-              <a:rPr lang="en-US" sz="2000"/>
-              <a:t>Nand2Tetris HDL Guide / Documentation:</a:t>
-            </a:r>
-          </a:p>
-          <a:p>
-            <a:pPr marL="0" lvl="1" indent="0">
-              <a:lnSpc>
-                <a:spcPct val="100000"/>
-              </a:lnSpc>
-              <a:spcBef>
-                <a:spcPts val="600"/>
-              </a:spcBef>
-              <a:buSzPct val="100000"/>
-              <a:buNone/>
-            </a:pPr>
-            <a:r>
-              <a:rPr lang="en-US" sz="2000" i="1">
-                <a:hlinkClick r:id="rId2"/>
-              </a:rPr>
-              <a:t>The Elements of Computing Systems</a:t>
-            </a:r>
-            <a:r>
-              <a:rPr lang="en-US" sz="2000">
-                <a:hlinkClick r:id="rId2"/>
-              </a:rPr>
-              <a:t> / Appendix 2: HDL</a:t>
-            </a:r>
-            <a:endParaRPr lang="en-US" sz="2000"/>
-          </a:p>
-        </p:txBody>
-      </p:sp>
-    </p:spTree>
-    <p:extLst>
-      <p:ext uri="{BB962C8B-B14F-4D97-AF65-F5344CB8AC3E}">
-        <p14:creationId xmlns:p14="http://schemas.microsoft.com/office/powerpoint/2010/main" val="3010950633"/>
       </p:ext>
     </p:extLst>
   </p:cSld>

</xml_diff>